<commit_message>
Phase 6 results: memory raises pair stability, the rise is marginal
All three graded criteria pass, 30 seeds, 22 weeks.

  purchase_rate 0.693 (attendance 0.845)
  stability 0.420 with loyalty vs 0.312 control, +0.1086
    95% CI [+0.1049, +0.1124]
  rise week 1 -> weeks 17-21 +0.0372, CI [+0.0083, +0.0661]
  plateau week 14

The control comparison is the finding. It is an order of magnitude
better separated than the rise and depends on no window choice, and the
SEM bands of the two arms do not overlap in any week.

The control's own 0.312 is not memory: unequal seller popularity and
season-long fixed preference produce most of it. Reporting the raw 0.420
as a loyalty effect would overstate it roughly fivefold.

experiment_log now carries a clean hash on every row for the first time -
11 rows at 2c9f9e7, none dirty - because the run happened against a
committed source tree, which is what the three-commit order is for.
</commit_message>
<xml_diff>
--- a/project_tracking.pptx
+++ b/project_tracking.pptx
@@ -10,6 +10,7 @@
     <p:sldId id="258" r:id="rId9"/>
     <p:sldId id="259" r:id="rId10"/>
     <p:sldId id="260" r:id="rId11"/>
+    <p:sldId id="261" r:id="rId12"/>
   </p:sldIdLst>
   <p:sldSz cx="12191969" cy="6858000" type="screen4x3"/>
   <p:notesSz cx="6858000" cy="9144000"/>
@@ -10541,6 +10542,1543 @@
 </p:sld>
 </file>
 
+<file path=ppt/slides/slide6.xml><?xml version="1.0" encoding="utf-8"?>
+<p:sld xmlns:a="http://schemas.openxmlformats.org/drawingml/2006/main" xmlns:p="http://schemas.openxmlformats.org/presentationml/2006/main" xmlns:r="http://schemas.openxmlformats.org/officeDocument/2006/relationships">
+  <p:cSld>
+    <p:spTree>
+      <p:nvGrpSpPr>
+        <p:cNvPr id="1" name=""/>
+        <p:cNvGrpSpPr/>
+        <p:nvPr/>
+      </p:nvGrpSpPr>
+      <p:grpSpPr/>
+      <p:sp>
+        <p:nvSpPr>
+          <p:cNvPr id="2" name="TextBox 1"/>
+          <p:cNvSpPr txBox="1"/>
+          <p:nvPr/>
+        </p:nvSpPr>
+        <p:spPr>
+          <a:xfrm>
+            <a:off x="457200" y="320040"/>
+            <a:ext cx="8229600" cy="548640"/>
+          </a:xfrm>
+          <a:prstGeom prst="rect">
+            <a:avLst/>
+          </a:prstGeom>
+          <a:noFill/>
+        </p:spPr>
+        <p:txBody>
+          <a:bodyPr wrap="square" lIns="0" rIns="0" tIns="0" bIns="0">
+            <a:spAutoFit/>
+          </a:bodyPr>
+          <a:lstStyle/>
+          <a:p>
+            <a:pPr>
+              <a:spcAft>
+                <a:spcPts val="200"/>
+              </a:spcAft>
+            </a:pPr>
+            <a:r>
+              <a:rPr sz="3200" b="1">
+                <a:solidFill>
+                  <a:srgbClr val="1E2761"/>
+                </a:solidFill>
+                <a:latin typeface="Cambria"/>
+              </a:rPr>
+              <a:t>Phase 6 — Repeated Interaction</a:t>
+            </a:r>
+          </a:p>
+        </p:txBody>
+      </p:sp>
+      <p:sp>
+        <p:nvSpPr>
+          <p:cNvPr id="3" name="TextBox 2"/>
+          <p:cNvSpPr txBox="1"/>
+          <p:nvPr/>
+        </p:nvSpPr>
+        <p:spPr>
+          <a:xfrm>
+            <a:off x="457200" y="868680"/>
+            <a:ext cx="8229600" cy="274320"/>
+          </a:xfrm>
+          <a:prstGeom prst="rect">
+            <a:avLst/>
+          </a:prstGeom>
+          <a:noFill/>
+        </p:spPr>
+        <p:txBody>
+          <a:bodyPr wrap="square" lIns="0" rIns="0" tIns="0" bIns="0">
+            <a:spAutoFit/>
+          </a:bodyPr>
+          <a:lstStyle/>
+          <a:p>
+            <a:pPr>
+              <a:spcAft>
+                <a:spcPts val="200"/>
+              </a:spcAft>
+            </a:pPr>
+            <a:r>
+              <a:rPr sz="1200" b="0">
+                <a:solidFill>
+                  <a:srgbClr val="5B5F6E"/>
+                </a:solidFill>
+                <a:latin typeface="Calibri"/>
+              </a:rPr>
+              <a:t>22-week season, accumulating memory  ·  git tag: phase6-validated  ·  30 seeds</a:t>
+            </a:r>
+          </a:p>
+        </p:txBody>
+      </p:sp>
+      <p:sp>
+        <p:nvSpPr>
+          <p:cNvPr id="4" name="Rounded Rectangle 3"/>
+          <p:cNvSpPr/>
+          <p:nvPr/>
+        </p:nvSpPr>
+        <p:spPr>
+          <a:xfrm>
+            <a:off x="9464040" y="365760"/>
+            <a:ext cx="2240280" cy="384048"/>
+          </a:xfrm>
+          <a:prstGeom prst="roundRect">
+            <a:avLst/>
+          </a:prstGeom>
+          <a:solidFill>
+            <a:srgbClr val="1E7A4D"/>
+          </a:solidFill>
+          <a:ln>
+            <a:noFill/>
+          </a:ln>
+        </p:spPr>
+        <p:style>
+          <a:lnRef idx="1">
+            <a:schemeClr val="accent1"/>
+          </a:lnRef>
+          <a:fillRef idx="3">
+            <a:schemeClr val="accent1"/>
+          </a:fillRef>
+          <a:effectRef idx="2">
+            <a:schemeClr val="accent1"/>
+          </a:effectRef>
+          <a:fontRef idx="minor">
+            <a:schemeClr val="lt1"/>
+          </a:fontRef>
+        </p:style>
+        <p:txBody>
+          <a:bodyPr rtlCol="0" anchor="ctr"/>
+          <a:lstStyle/>
+          <a:p>
+            <a:pPr algn="ctr"/>
+            <a:r>
+              <a:rPr sz="1050" b="1">
+                <a:solidFill>
+                  <a:srgbClr val="FFFFFF"/>
+                </a:solidFill>
+                <a:latin typeface="Calibri"/>
+              </a:rPr>
+              <a:t>ALL CRITERIA PASS</a:t>
+            </a:r>
+          </a:p>
+        </p:txBody>
+      </p:sp>
+      <p:sp>
+        <p:nvSpPr>
+          <p:cNvPr id="5" name="Rectangle 4"/>
+          <p:cNvSpPr/>
+          <p:nvPr/>
+        </p:nvSpPr>
+        <p:spPr>
+          <a:xfrm>
+            <a:off x="457200" y="1417320"/>
+            <a:ext cx="292608" cy="292608"/>
+          </a:xfrm>
+          <a:prstGeom prst="rect">
+            <a:avLst/>
+          </a:prstGeom>
+          <a:solidFill>
+            <a:srgbClr val="1E2761"/>
+          </a:solidFill>
+          <a:ln>
+            <a:noFill/>
+          </a:ln>
+        </p:spPr>
+        <p:style>
+          <a:lnRef idx="1">
+            <a:schemeClr val="accent1"/>
+          </a:lnRef>
+          <a:fillRef idx="3">
+            <a:schemeClr val="accent1"/>
+          </a:fillRef>
+          <a:effectRef idx="2">
+            <a:schemeClr val="accent1"/>
+          </a:effectRef>
+          <a:fontRef idx="minor">
+            <a:schemeClr val="lt1"/>
+          </a:fontRef>
+        </p:style>
+        <p:txBody>
+          <a:bodyPr rtlCol="0" anchor="ctr"/>
+          <a:lstStyle/>
+          <a:p/>
+        </p:txBody>
+      </p:sp>
+      <p:sp>
+        <p:nvSpPr>
+          <p:cNvPr id="6" name="TextBox 5"/>
+          <p:cNvSpPr txBox="1"/>
+          <p:nvPr/>
+        </p:nvSpPr>
+        <p:spPr>
+          <a:xfrm>
+            <a:off x="868680" y="1389888"/>
+            <a:ext cx="4617720" cy="347472"/>
+          </a:xfrm>
+          <a:prstGeom prst="rect">
+            <a:avLst/>
+          </a:prstGeom>
+          <a:noFill/>
+        </p:spPr>
+        <p:txBody>
+          <a:bodyPr wrap="square" lIns="0" rIns="0" tIns="0" bIns="0">
+            <a:spAutoFit/>
+          </a:bodyPr>
+          <a:lstStyle/>
+          <a:p>
+            <a:pPr>
+              <a:spcAft>
+                <a:spcPts val="200"/>
+              </a:spcAft>
+            </a:pPr>
+            <a:r>
+              <a:rPr sz="1500" b="1">
+                <a:solidFill>
+                  <a:srgbClr val="1E2761"/>
+                </a:solidFill>
+                <a:latin typeface="Calibri"/>
+              </a:rPr>
+              <a:t>AGENTS</a:t>
+            </a:r>
+          </a:p>
+        </p:txBody>
+      </p:sp>
+      <p:sp>
+        <p:nvSpPr>
+          <p:cNvPr id="7" name="TextBox 6"/>
+          <p:cNvSpPr txBox="1"/>
+          <p:nvPr/>
+        </p:nvSpPr>
+        <p:spPr>
+          <a:xfrm>
+            <a:off x="868680" y="1828800"/>
+            <a:ext cx="4617720" cy="566928"/>
+          </a:xfrm>
+          <a:prstGeom prst="rect">
+            <a:avLst/>
+          </a:prstGeom>
+          <a:noFill/>
+        </p:spPr>
+        <p:txBody>
+          <a:bodyPr wrap="square" lIns="0" rIns="0" tIns="0" bIns="0">
+            <a:spAutoFit/>
+          </a:bodyPr>
+          <a:lstStyle/>
+          <a:p>
+            <a:pPr>
+              <a:spcAft>
+                <a:spcPts val="200"/>
+              </a:spcAft>
+            </a:pPr>
+            <a:r>
+              <a:rPr sz="1300" b="1">
+                <a:solidFill>
+                  <a:srgbClr val="1E2761"/>
+                </a:solidFill>
+                <a:latin typeface="Calibri"/>
+              </a:rPr>
+              <a:t>Buyers: </a:t>
+            </a:r>
+            <a:r>
+              <a:rPr sz="1300" b="0">
+                <a:solidFill>
+                  <a:srgbClr val="5B5F6E"/>
+                </a:solidFill>
+                <a:latin typeface="Calibri"/>
+              </a:rPr>
+              <a:t>100 — Poor 70 / Middle 20 / Rich 10; attendance 0.85 / 0.84 / 0.82</a:t>
+            </a:r>
+          </a:p>
+          <a:p>
+            <a:pPr>
+              <a:spcAft>
+                <a:spcPts val="200"/>
+              </a:spcAft>
+            </a:pPr>
+            <a:r>
+              <a:rPr sz="1300" b="1">
+                <a:solidFill>
+                  <a:srgbClr val="1E2761"/>
+                </a:solidFill>
+                <a:latin typeface="Calibri"/>
+              </a:rPr>
+              <a:t>Sellers: </a:t>
+            </a:r>
+            <a:r>
+              <a:rPr sz="1300" b="0">
+                <a:solidFill>
+                  <a:srgbClr val="5B5F6E"/>
+                </a:solidFill>
+                <a:latin typeface="Calibri"/>
+              </a:rPr>
+              <a:t>5 — Slow ×3 / Shigh ×2, positions and promotion from Phases 3–4</a:t>
+            </a:r>
+          </a:p>
+        </p:txBody>
+      </p:sp>
+      <p:sp>
+        <p:nvSpPr>
+          <p:cNvPr id="8" name="Rectangle 7"/>
+          <p:cNvSpPr/>
+          <p:nvPr/>
+        </p:nvSpPr>
+        <p:spPr>
+          <a:xfrm>
+            <a:off x="457200" y="2651760"/>
+            <a:ext cx="292608" cy="292608"/>
+          </a:xfrm>
+          <a:prstGeom prst="rect">
+            <a:avLst/>
+          </a:prstGeom>
+          <a:solidFill>
+            <a:srgbClr val="1E2761"/>
+          </a:solidFill>
+          <a:ln>
+            <a:noFill/>
+          </a:ln>
+        </p:spPr>
+        <p:style>
+          <a:lnRef idx="1">
+            <a:schemeClr val="accent1"/>
+          </a:lnRef>
+          <a:fillRef idx="3">
+            <a:schemeClr val="accent1"/>
+          </a:fillRef>
+          <a:effectRef idx="2">
+            <a:schemeClr val="accent1"/>
+          </a:effectRef>
+          <a:fontRef idx="minor">
+            <a:schemeClr val="lt1"/>
+          </a:fontRef>
+        </p:style>
+        <p:txBody>
+          <a:bodyPr rtlCol="0" anchor="ctr"/>
+          <a:lstStyle/>
+          <a:p/>
+        </p:txBody>
+      </p:sp>
+      <p:sp>
+        <p:nvSpPr>
+          <p:cNvPr id="9" name="TextBox 8"/>
+          <p:cNvSpPr txBox="1"/>
+          <p:nvPr/>
+        </p:nvSpPr>
+        <p:spPr>
+          <a:xfrm>
+            <a:off x="868680" y="2624328"/>
+            <a:ext cx="4617720" cy="347472"/>
+          </a:xfrm>
+          <a:prstGeom prst="rect">
+            <a:avLst/>
+          </a:prstGeom>
+          <a:noFill/>
+        </p:spPr>
+        <p:txBody>
+          <a:bodyPr wrap="square" lIns="0" rIns="0" tIns="0" bIns="0">
+            <a:spAutoFit/>
+          </a:bodyPr>
+          <a:lstStyle/>
+          <a:p>
+            <a:pPr>
+              <a:spcAft>
+                <a:spcPts val="200"/>
+              </a:spcAft>
+            </a:pPr>
+            <a:r>
+              <a:rPr sz="1500" b="1">
+                <a:solidFill>
+                  <a:srgbClr val="1E2761"/>
+                </a:solidFill>
+                <a:latin typeface="Calibri"/>
+              </a:rPr>
+              <a:t>ENVIRONMENT &amp; CONTEXT</a:t>
+            </a:r>
+          </a:p>
+        </p:txBody>
+      </p:sp>
+      <p:sp>
+        <p:nvSpPr>
+          <p:cNvPr id="10" name="TextBox 9"/>
+          <p:cNvSpPr txBox="1"/>
+          <p:nvPr/>
+        </p:nvSpPr>
+        <p:spPr>
+          <a:xfrm>
+            <a:off x="868680" y="3063240"/>
+            <a:ext cx="4617720" cy="548640"/>
+          </a:xfrm>
+          <a:prstGeom prst="rect">
+            <a:avLst/>
+          </a:prstGeom>
+          <a:noFill/>
+        </p:spPr>
+        <p:txBody>
+          <a:bodyPr wrap="square" lIns="0" rIns="0" tIns="0" bIns="0">
+            <a:spAutoFit/>
+          </a:bodyPr>
+          <a:lstStyle/>
+          <a:p>
+            <a:pPr>
+              <a:spcAft>
+                <a:spcPts val="200"/>
+              </a:spcAft>
+            </a:pPr>
+            <a:r>
+              <a:rPr sz="1300" b="0">
+                <a:solidFill>
+                  <a:srgbClr val="5B5F6E"/>
+                </a:solidFill>
+                <a:latin typeface="Calibri"/>
+              </a:rPr>
+              <a:t>-  Time axis: 22 weeks, one season. Budget and inventory reset weekly.</a:t>
+            </a:r>
+          </a:p>
+          <a:p>
+            <a:pPr>
+              <a:spcAft>
+                <a:spcPts val="200"/>
+              </a:spcAft>
+            </a:pPr>
+            <a:r>
+              <a:rPr sz="1300" b="0">
+                <a:solidFill>
+                  <a:srgbClr val="5B5F6E"/>
+                </a:solidFill>
+                <a:latin typeface="Calibri"/>
+              </a:rPr>
+              <a:t>-  Memory persists across weeks, including weeks a buyer sits out.</a:t>
+            </a:r>
+          </a:p>
+        </p:txBody>
+      </p:sp>
+      <p:sp>
+        <p:nvSpPr>
+          <p:cNvPr id="11" name="Rectangle 10"/>
+          <p:cNvSpPr/>
+          <p:nvPr/>
+        </p:nvSpPr>
+        <p:spPr>
+          <a:xfrm>
+            <a:off x="457200" y="3886200"/>
+            <a:ext cx="292608" cy="292608"/>
+          </a:xfrm>
+          <a:prstGeom prst="rect">
+            <a:avLst/>
+          </a:prstGeom>
+          <a:solidFill>
+            <a:srgbClr val="1E2761"/>
+          </a:solidFill>
+          <a:ln>
+            <a:noFill/>
+          </a:ln>
+        </p:spPr>
+        <p:style>
+          <a:lnRef idx="1">
+            <a:schemeClr val="accent1"/>
+          </a:lnRef>
+          <a:fillRef idx="3">
+            <a:schemeClr val="accent1"/>
+          </a:fillRef>
+          <a:effectRef idx="2">
+            <a:schemeClr val="accent1"/>
+          </a:effectRef>
+          <a:fontRef idx="minor">
+            <a:schemeClr val="lt1"/>
+          </a:fontRef>
+        </p:style>
+        <p:txBody>
+          <a:bodyPr rtlCol="0" anchor="ctr"/>
+          <a:lstStyle/>
+          <a:p/>
+        </p:txBody>
+      </p:sp>
+      <p:sp>
+        <p:nvSpPr>
+          <p:cNvPr id="12" name="TextBox 11"/>
+          <p:cNvSpPr txBox="1"/>
+          <p:nvPr/>
+        </p:nvSpPr>
+        <p:spPr>
+          <a:xfrm>
+            <a:off x="868680" y="3858768"/>
+            <a:ext cx="4617720" cy="347472"/>
+          </a:xfrm>
+          <a:prstGeom prst="rect">
+            <a:avLst/>
+          </a:prstGeom>
+          <a:noFill/>
+        </p:spPr>
+        <p:txBody>
+          <a:bodyPr wrap="square" lIns="0" rIns="0" tIns="0" bIns="0">
+            <a:spAutoFit/>
+          </a:bodyPr>
+          <a:lstStyle/>
+          <a:p>
+            <a:pPr>
+              <a:spcAft>
+                <a:spcPts val="200"/>
+              </a:spcAft>
+            </a:pPr>
+            <a:r>
+              <a:rPr sz="1500" b="1">
+                <a:solidFill>
+                  <a:srgbClr val="1E2761"/>
+                </a:solidFill>
+                <a:latin typeface="Calibri"/>
+              </a:rPr>
+              <a:t>METHOD</a:t>
+            </a:r>
+          </a:p>
+        </p:txBody>
+      </p:sp>
+      <p:sp>
+        <p:nvSpPr>
+          <p:cNvPr id="13" name="TextBox 12"/>
+          <p:cNvSpPr txBox="1"/>
+          <p:nvPr/>
+        </p:nvSpPr>
+        <p:spPr>
+          <a:xfrm>
+            <a:off x="868680" y="4297680"/>
+            <a:ext cx="4617720" cy="594360"/>
+          </a:xfrm>
+          <a:prstGeom prst="rect">
+            <a:avLst/>
+          </a:prstGeom>
+          <a:noFill/>
+        </p:spPr>
+        <p:txBody>
+          <a:bodyPr wrap="square" lIns="0" rIns="0" tIns="0" bIns="0">
+            <a:spAutoFit/>
+          </a:bodyPr>
+          <a:lstStyle/>
+          <a:p>
+            <a:pPr>
+              <a:spcAft>
+                <a:spcPts val="200"/>
+              </a:spcAft>
+            </a:pPr>
+            <a:r>
+              <a:rPr sz="1300" b="0">
+                <a:solidFill>
+                  <a:srgbClr val="5B5F6E"/>
+                </a:solidFill>
+                <a:latin typeface="Calibri"/>
+              </a:rPr>
+              <a:t>Loyalty bonus 0.5 × min(streak, 3), max 1.5 = preference_coef.</a:t>
+            </a:r>
+          </a:p>
+          <a:p>
+            <a:pPr>
+              <a:spcAft>
+                <a:spcPts val="200"/>
+              </a:spcAft>
+            </a:pPr>
+            <a:r>
+              <a:rPr sz="1300" b="0">
+                <a:solidFill>
+                  <a:srgbClr val="5B5F6E"/>
+                </a:solidFill>
+                <a:latin typeface="Calibri"/>
+              </a:rPr>
+              <a:t>Linear single-week model, per Phase 5's rollback. Graded vs a no-loyalty control.</a:t>
+            </a:r>
+          </a:p>
+        </p:txBody>
+      </p:sp>
+      <p:sp>
+        <p:nvSpPr>
+          <p:cNvPr id="14" name="Rectangle 13"/>
+          <p:cNvSpPr/>
+          <p:nvPr/>
+        </p:nvSpPr>
+        <p:spPr>
+          <a:xfrm>
+            <a:off x="457200" y="5029200"/>
+            <a:ext cx="292608" cy="292608"/>
+          </a:xfrm>
+          <a:prstGeom prst="rect">
+            <a:avLst/>
+          </a:prstGeom>
+          <a:solidFill>
+            <a:srgbClr val="1E2761"/>
+          </a:solidFill>
+          <a:ln>
+            <a:noFill/>
+          </a:ln>
+        </p:spPr>
+        <p:style>
+          <a:lnRef idx="1">
+            <a:schemeClr val="accent1"/>
+          </a:lnRef>
+          <a:fillRef idx="3">
+            <a:schemeClr val="accent1"/>
+          </a:fillRef>
+          <a:effectRef idx="2">
+            <a:schemeClr val="accent1"/>
+          </a:effectRef>
+          <a:fontRef idx="minor">
+            <a:schemeClr val="lt1"/>
+          </a:fontRef>
+        </p:style>
+        <p:txBody>
+          <a:bodyPr rtlCol="0" anchor="ctr"/>
+          <a:lstStyle/>
+          <a:p/>
+        </p:txBody>
+      </p:sp>
+      <p:sp>
+        <p:nvSpPr>
+          <p:cNvPr id="15" name="TextBox 14"/>
+          <p:cNvSpPr txBox="1"/>
+          <p:nvPr/>
+        </p:nvSpPr>
+        <p:spPr>
+          <a:xfrm>
+            <a:off x="868680" y="5001768"/>
+            <a:ext cx="4617720" cy="347472"/>
+          </a:xfrm>
+          <a:prstGeom prst="rect">
+            <a:avLst/>
+          </a:prstGeom>
+          <a:noFill/>
+        </p:spPr>
+        <p:txBody>
+          <a:bodyPr wrap="square" lIns="0" rIns="0" tIns="0" bIns="0">
+            <a:spAutoFit/>
+          </a:bodyPr>
+          <a:lstStyle/>
+          <a:p>
+            <a:pPr>
+              <a:spcAft>
+                <a:spcPts val="200"/>
+              </a:spcAft>
+            </a:pPr>
+            <a:r>
+              <a:rPr sz="1500" b="1">
+                <a:solidFill>
+                  <a:srgbClr val="1E2761"/>
+                </a:solidFill>
+                <a:latin typeface="Calibri"/>
+              </a:rPr>
+              <a:t>LITERATURE BASIS</a:t>
+            </a:r>
+          </a:p>
+        </p:txBody>
+      </p:sp>
+      <p:sp>
+        <p:nvSpPr>
+          <p:cNvPr id="16" name="TextBox 15"/>
+          <p:cNvSpPr txBox="1"/>
+          <p:nvPr/>
+        </p:nvSpPr>
+        <p:spPr>
+          <a:xfrm>
+            <a:off x="868680" y="5440680"/>
+            <a:ext cx="4617720" cy="1005840"/>
+          </a:xfrm>
+          <a:prstGeom prst="rect">
+            <a:avLst/>
+          </a:prstGeom>
+          <a:noFill/>
+        </p:spPr>
+        <p:txBody>
+          <a:bodyPr wrap="square" lIns="0" rIns="0" tIns="0" bIns="0">
+            <a:spAutoFit/>
+          </a:bodyPr>
+          <a:lstStyle/>
+          <a:p>
+            <a:pPr>
+              <a:spcAft>
+                <a:spcPts val="600"/>
+              </a:spcAft>
+            </a:pPr>
+            <a:r>
+              <a:rPr sz="1100" b="1">
+                <a:solidFill>
+                  <a:srgbClr val="1E2761"/>
+                </a:solidFill>
+                <a:latin typeface="Calibri"/>
+              </a:rPr>
+              <a:t>Massy, Montgomery &amp; Morrison (1970), </a:t>
+            </a:r>
+            <a:r>
+              <a:rPr sz="1100" b="0">
+                <a:solidFill>
+                  <a:srgbClr val="5B5F6E"/>
+                </a:solidFill>
+                <a:latin typeface="Calibri"/>
+              </a:rPr>
+              <a:t>“Stochastic Models of Buying Behavior” (MIT Press) — loyalty and switching dynamics in repeated purchasing.</a:t>
+            </a:r>
+          </a:p>
+        </p:txBody>
+      </p:sp>
+      <p:sp>
+        <p:nvSpPr>
+          <p:cNvPr id="17" name="Rectangle 16"/>
+          <p:cNvSpPr/>
+          <p:nvPr/>
+        </p:nvSpPr>
+        <p:spPr>
+          <a:xfrm>
+            <a:off x="5943600" y="1417320"/>
+            <a:ext cx="292608" cy="292608"/>
+          </a:xfrm>
+          <a:prstGeom prst="rect">
+            <a:avLst/>
+          </a:prstGeom>
+          <a:solidFill>
+            <a:srgbClr val="1E2761"/>
+          </a:solidFill>
+          <a:ln>
+            <a:noFill/>
+          </a:ln>
+        </p:spPr>
+        <p:style>
+          <a:lnRef idx="1">
+            <a:schemeClr val="accent1"/>
+          </a:lnRef>
+          <a:fillRef idx="3">
+            <a:schemeClr val="accent1"/>
+          </a:fillRef>
+          <a:effectRef idx="2">
+            <a:schemeClr val="accent1"/>
+          </a:effectRef>
+          <a:fontRef idx="minor">
+            <a:schemeClr val="lt1"/>
+          </a:fontRef>
+        </p:style>
+        <p:txBody>
+          <a:bodyPr rtlCol="0" anchor="ctr"/>
+          <a:lstStyle/>
+          <a:p/>
+        </p:txBody>
+      </p:sp>
+      <p:sp>
+        <p:nvSpPr>
+          <p:cNvPr id="18" name="TextBox 17"/>
+          <p:cNvSpPr txBox="1"/>
+          <p:nvPr/>
+        </p:nvSpPr>
+        <p:spPr>
+          <a:xfrm>
+            <a:off x="6355080" y="1389888"/>
+            <a:ext cx="5349240" cy="347472"/>
+          </a:xfrm>
+          <a:prstGeom prst="rect">
+            <a:avLst/>
+          </a:prstGeom>
+          <a:noFill/>
+        </p:spPr>
+        <p:txBody>
+          <a:bodyPr wrap="square" lIns="0" rIns="0" tIns="0" bIns="0">
+            <a:spAutoFit/>
+          </a:bodyPr>
+          <a:lstStyle/>
+          <a:p>
+            <a:pPr>
+              <a:spcAft>
+                <a:spcPts val="200"/>
+              </a:spcAft>
+            </a:pPr>
+            <a:r>
+              <a:rPr sz="1500" b="1">
+                <a:solidFill>
+                  <a:srgbClr val="1E2761"/>
+                </a:solidFill>
+                <a:latin typeface="Calibri"/>
+              </a:rPr>
+              <a:t>KEY RESULTS</a:t>
+            </a:r>
+          </a:p>
+        </p:txBody>
+      </p:sp>
+      <p:graphicFrame>
+        <p:nvGraphicFramePr>
+          <p:cNvPr id="19" name="Table 18"/>
+          <p:cNvGraphicFramePr>
+            <a:graphicFrameLocks noGrp="1"/>
+          </p:cNvGraphicFramePr>
+          <p:nvPr/>
+        </p:nvGraphicFramePr>
+        <p:xfrm>
+          <a:off x="5943600" y="1874519"/>
+          <a:ext cx="5760720" cy="1920240"/>
+        </p:xfrm>
+        <a:graphic>
+          <a:graphicData uri="http://schemas.openxmlformats.org/drawingml/2006/table">
+            <a:tbl>
+              <a:tblPr firstRow="1" bandRow="1">
+                <a:tableStyleId>{5C22544A-7EE6-4342-B048-85BDC9FD1C3A}</a:tableStyleId>
+              </a:tblPr>
+              <a:tblGrid>
+                <a:gridCol w="3200400"/>
+                <a:gridCol w="1463040"/>
+                <a:gridCol w="1097280"/>
+              </a:tblGrid>
+              <a:tr h="274320">
+                <a:tc>
+                  <a:txBody>
+                    <a:bodyPr/>
+                    <a:lstStyle/>
+                    <a:p>
+                      <a:r>
+                        <a:rPr sz="1100" b="1">
+                          <a:solidFill>
+                            <a:srgbClr val="FFFFFF"/>
+                          </a:solidFill>
+                          <a:latin typeface="Calibri"/>
+                        </a:rPr>
+                        <a:t>Metric</a:t>
+                      </a:r>
+                    </a:p>
+                  </a:txBody>
+                  <a:tcPr>
+                    <a:solidFill>
+                      <a:srgbClr val="1E2761"/>
+                    </a:solidFill>
+                  </a:tcPr>
+                </a:tc>
+                <a:tc>
+                  <a:txBody>
+                    <a:bodyPr/>
+                    <a:lstStyle/>
+                    <a:p>
+                      <a:r>
+                        <a:rPr sz="1100" b="1">
+                          <a:solidFill>
+                            <a:srgbClr val="FFFFFF"/>
+                          </a:solidFill>
+                          <a:latin typeface="Calibri"/>
+                        </a:rPr>
+                        <a:t>Value</a:t>
+                      </a:r>
+                    </a:p>
+                  </a:txBody>
+                  <a:tcPr>
+                    <a:solidFill>
+                      <a:srgbClr val="1E2761"/>
+                    </a:solidFill>
+                  </a:tcPr>
+                </a:tc>
+                <a:tc>
+                  <a:txBody>
+                    <a:bodyPr/>
+                    <a:lstStyle/>
+                    <a:p>
+                      <a:r>
+                        <a:rPr sz="1100" b="1">
+                          <a:solidFill>
+                            <a:srgbClr val="FFFFFF"/>
+                          </a:solidFill>
+                          <a:latin typeface="Calibri"/>
+                        </a:rPr>
+                        <a:t/>
+                      </a:r>
+                    </a:p>
+                  </a:txBody>
+                  <a:tcPr>
+                    <a:solidFill>
+                      <a:srgbClr val="1E2761"/>
+                    </a:solidFill>
+                  </a:tcPr>
+                </a:tc>
+              </a:tr>
+              <a:tr h="274320">
+                <a:tc>
+                  <a:txBody>
+                    <a:bodyPr/>
+                    <a:lstStyle/>
+                    <a:p>
+                      <a:r>
+                        <a:rPr sz="1100">
+                          <a:solidFill>
+                            <a:srgbClr val="1E2761"/>
+                          </a:solidFill>
+                          <a:latin typeface="Calibri"/>
+                        </a:rPr>
+                        <a:t>purchase_rate (0.6–1.0)</a:t>
+                      </a:r>
+                    </a:p>
+                  </a:txBody>
+                  <a:tcPr>
+                    <a:solidFill>
+                      <a:srgbClr val="FFFFFF"/>
+                    </a:solidFill>
+                  </a:tcPr>
+                </a:tc>
+                <a:tc>
+                  <a:txBody>
+                    <a:bodyPr/>
+                    <a:lstStyle/>
+                    <a:p>
+                      <a:r>
+                        <a:rPr sz="1100">
+                          <a:solidFill>
+                            <a:srgbClr val="5B5F6E"/>
+                          </a:solidFill>
+                          <a:latin typeface="Calibri"/>
+                        </a:rPr>
+                        <a:t>0.693</a:t>
+                      </a:r>
+                    </a:p>
+                  </a:txBody>
+                  <a:tcPr>
+                    <a:solidFill>
+                      <a:srgbClr val="FFFFFF"/>
+                    </a:solidFill>
+                  </a:tcPr>
+                </a:tc>
+                <a:tc>
+                  <a:txBody>
+                    <a:bodyPr/>
+                    <a:lstStyle/>
+                    <a:p>
+                      <a:pPr algn="ctr"/>
+                      <a:r>
+                        <a:rPr sz="1100" b="1">
+                          <a:solidFill>
+                            <a:srgbClr val="1E7A4D"/>
+                          </a:solidFill>
+                          <a:latin typeface="Calibri"/>
+                        </a:rPr>
+                        <a:t>PASS</a:t>
+                      </a:r>
+                    </a:p>
+                  </a:txBody>
+                  <a:tcPr>
+                    <a:solidFill>
+                      <a:srgbClr val="FFFFFF"/>
+                    </a:solidFill>
+                  </a:tcPr>
+                </a:tc>
+              </a:tr>
+              <a:tr h="274320">
+                <a:tc>
+                  <a:txBody>
+                    <a:bodyPr/>
+                    <a:lstStyle/>
+                    <a:p>
+                      <a:r>
+                        <a:rPr sz="1100">
+                          <a:solidFill>
+                            <a:srgbClr val="1E2761"/>
+                          </a:solidFill>
+                          <a:latin typeface="Calibri"/>
+                        </a:rPr>
+                        <a:t>  attendance_rate (reported)</a:t>
+                      </a:r>
+                    </a:p>
+                  </a:txBody>
+                  <a:tcPr>
+                    <a:solidFill>
+                      <a:srgbClr val="F7F8FC"/>
+                    </a:solidFill>
+                  </a:tcPr>
+                </a:tc>
+                <a:tc>
+                  <a:txBody>
+                    <a:bodyPr/>
+                    <a:lstStyle/>
+                    <a:p>
+                      <a:r>
+                        <a:rPr sz="1100">
+                          <a:solidFill>
+                            <a:srgbClr val="5B5F6E"/>
+                          </a:solidFill>
+                          <a:latin typeface="Calibri"/>
+                        </a:rPr>
+                        <a:t>0.845</a:t>
+                      </a:r>
+                    </a:p>
+                  </a:txBody>
+                  <a:tcPr>
+                    <a:solidFill>
+                      <a:srgbClr val="F7F8FC"/>
+                    </a:solidFill>
+                  </a:tcPr>
+                </a:tc>
+                <a:tc>
+                  <a:txBody>
+                    <a:bodyPr/>
+                    <a:lstStyle/>
+                    <a:p>
+                      <a:pPr algn="ctr"/>
+                      <a:r>
+                        <a:rPr sz="1100" b="1">
+                          <a:solidFill>
+                            <a:srgbClr val="5B5F6E"/>
+                          </a:solidFill>
+                          <a:latin typeface="Calibri"/>
+                        </a:rPr>
+                        <a:t>—</a:t>
+                      </a:r>
+                    </a:p>
+                  </a:txBody>
+                  <a:tcPr>
+                    <a:solidFill>
+                      <a:srgbClr val="F7F8FC"/>
+                    </a:solidFill>
+                  </a:tcPr>
+                </a:tc>
+              </a:tr>
+              <a:tr h="274320">
+                <a:tc>
+                  <a:txBody>
+                    <a:bodyPr/>
+                    <a:lstStyle/>
+                    <a:p>
+                      <a:r>
+                        <a:rPr sz="1100">
+                          <a:solidFill>
+                            <a:srgbClr val="1E2761"/>
+                          </a:solidFill>
+                          <a:latin typeface="Calibri"/>
+                        </a:rPr>
+                        <a:t>Stability vs no-loyalty control</a:t>
+                      </a:r>
+                    </a:p>
+                  </a:txBody>
+                  <a:tcPr>
+                    <a:solidFill>
+                      <a:srgbClr val="FFFFFF"/>
+                    </a:solidFill>
+                  </a:tcPr>
+                </a:tc>
+                <a:tc>
+                  <a:txBody>
+                    <a:bodyPr/>
+                    <a:lstStyle/>
+                    <a:p>
+                      <a:r>
+                        <a:rPr sz="1100">
+                          <a:solidFill>
+                            <a:srgbClr val="5B5F6E"/>
+                          </a:solidFill>
+                          <a:latin typeface="Calibri"/>
+                        </a:rPr>
+                        <a:t>+0.109</a:t>
+                      </a:r>
+                    </a:p>
+                  </a:txBody>
+                  <a:tcPr>
+                    <a:solidFill>
+                      <a:srgbClr val="FFFFFF"/>
+                    </a:solidFill>
+                  </a:tcPr>
+                </a:tc>
+                <a:tc>
+                  <a:txBody>
+                    <a:bodyPr/>
+                    <a:lstStyle/>
+                    <a:p>
+                      <a:pPr algn="ctr"/>
+                      <a:r>
+                        <a:rPr sz="1100" b="1">
+                          <a:solidFill>
+                            <a:srgbClr val="1E7A4D"/>
+                          </a:solidFill>
+                          <a:latin typeface="Calibri"/>
+                        </a:rPr>
+                        <a:t>PASS</a:t>
+                      </a:r>
+                    </a:p>
+                  </a:txBody>
+                  <a:tcPr>
+                    <a:solidFill>
+                      <a:srgbClr val="FFFFFF"/>
+                    </a:solidFill>
+                  </a:tcPr>
+                </a:tc>
+              </a:tr>
+              <a:tr h="274320">
+                <a:tc>
+                  <a:txBody>
+                    <a:bodyPr/>
+                    <a:lstStyle/>
+                    <a:p>
+                      <a:r>
+                        <a:rPr sz="1100">
+                          <a:solidFill>
+                            <a:srgbClr val="1E2761"/>
+                          </a:solidFill>
+                          <a:latin typeface="Calibri"/>
+                        </a:rPr>
+                        <a:t>  its 95% CI</a:t>
+                      </a:r>
+                    </a:p>
+                  </a:txBody>
+                  <a:tcPr>
+                    <a:solidFill>
+                      <a:srgbClr val="F7F8FC"/>
+                    </a:solidFill>
+                  </a:tcPr>
+                </a:tc>
+                <a:tc>
+                  <a:txBody>
+                    <a:bodyPr/>
+                    <a:lstStyle/>
+                    <a:p>
+                      <a:r>
+                        <a:rPr sz="1100">
+                          <a:solidFill>
+                            <a:srgbClr val="5B5F6E"/>
+                          </a:solidFill>
+                          <a:latin typeface="Calibri"/>
+                        </a:rPr>
+                        <a:t>[+0.105, +0.112]</a:t>
+                      </a:r>
+                    </a:p>
+                  </a:txBody>
+                  <a:tcPr>
+                    <a:solidFill>
+                      <a:srgbClr val="F7F8FC"/>
+                    </a:solidFill>
+                  </a:tcPr>
+                </a:tc>
+                <a:tc>
+                  <a:txBody>
+                    <a:bodyPr/>
+                    <a:lstStyle/>
+                    <a:p>
+                      <a:pPr algn="ctr"/>
+                      <a:r>
+                        <a:rPr sz="1100" b="1">
+                          <a:solidFill>
+                            <a:srgbClr val="1E7A4D"/>
+                          </a:solidFill>
+                          <a:latin typeface="Calibri"/>
+                        </a:rPr>
+                        <a:t>PASS</a:t>
+                      </a:r>
+                    </a:p>
+                  </a:txBody>
+                  <a:tcPr>
+                    <a:solidFill>
+                      <a:srgbClr val="F7F8FC"/>
+                    </a:solidFill>
+                  </a:tcPr>
+                </a:tc>
+              </a:tr>
+              <a:tr h="274320">
+                <a:tc>
+                  <a:txBody>
+                    <a:bodyPr/>
+                    <a:lstStyle/>
+                    <a:p>
+                      <a:r>
+                        <a:rPr sz="1100">
+                          <a:solidFill>
+                            <a:srgbClr val="1E2761"/>
+                          </a:solidFill>
+                          <a:latin typeface="Calibri"/>
+                        </a:rPr>
+                        <a:t>Rise, week 1 → weeks 17–21</a:t>
+                      </a:r>
+                    </a:p>
+                  </a:txBody>
+                  <a:tcPr>
+                    <a:solidFill>
+                      <a:srgbClr val="FFFFFF"/>
+                    </a:solidFill>
+                  </a:tcPr>
+                </a:tc>
+                <a:tc>
+                  <a:txBody>
+                    <a:bodyPr/>
+                    <a:lstStyle/>
+                    <a:p>
+                      <a:r>
+                        <a:rPr sz="1100">
+                          <a:solidFill>
+                            <a:srgbClr val="5B5F6E"/>
+                          </a:solidFill>
+                          <a:latin typeface="Calibri"/>
+                        </a:rPr>
+                        <a:t>+0.037</a:t>
+                      </a:r>
+                    </a:p>
+                  </a:txBody>
+                  <a:tcPr>
+                    <a:solidFill>
+                      <a:srgbClr val="FFFFFF"/>
+                    </a:solidFill>
+                  </a:tcPr>
+                </a:tc>
+                <a:tc>
+                  <a:txBody>
+                    <a:bodyPr/>
+                    <a:lstStyle/>
+                    <a:p>
+                      <a:pPr algn="ctr"/>
+                      <a:r>
+                        <a:rPr sz="1100" b="1">
+                          <a:solidFill>
+                            <a:srgbClr val="1E7A4D"/>
+                          </a:solidFill>
+                          <a:latin typeface="Calibri"/>
+                        </a:rPr>
+                        <a:t>PASS</a:t>
+                      </a:r>
+                    </a:p>
+                  </a:txBody>
+                  <a:tcPr>
+                    <a:solidFill>
+                      <a:srgbClr val="FFFFFF"/>
+                    </a:solidFill>
+                  </a:tcPr>
+                </a:tc>
+              </a:tr>
+              <a:tr h="274320">
+                <a:tc>
+                  <a:txBody>
+                    <a:bodyPr/>
+                    <a:lstStyle/>
+                    <a:p>
+                      <a:r>
+                        <a:rPr sz="1100">
+                          <a:solidFill>
+                            <a:srgbClr val="1E2761"/>
+                          </a:solidFill>
+                          <a:latin typeface="Calibri"/>
+                        </a:rPr>
+                        <a:t>Plateau week</a:t>
+                      </a:r>
+                    </a:p>
+                  </a:txBody>
+                  <a:tcPr>
+                    <a:solidFill>
+                      <a:srgbClr val="F7F8FC"/>
+                    </a:solidFill>
+                  </a:tcPr>
+                </a:tc>
+                <a:tc>
+                  <a:txBody>
+                    <a:bodyPr/>
+                    <a:lstStyle/>
+                    <a:p>
+                      <a:r>
+                        <a:rPr sz="1100">
+                          <a:solidFill>
+                            <a:srgbClr val="5B5F6E"/>
+                          </a:solidFill>
+                          <a:latin typeface="Calibri"/>
+                        </a:rPr>
+                        <a:t>week 14</a:t>
+                      </a:r>
+                    </a:p>
+                  </a:txBody>
+                  <a:tcPr>
+                    <a:solidFill>
+                      <a:srgbClr val="F7F8FC"/>
+                    </a:solidFill>
+                  </a:tcPr>
+                </a:tc>
+                <a:tc>
+                  <a:txBody>
+                    <a:bodyPr/>
+                    <a:lstStyle/>
+                    <a:p>
+                      <a:pPr algn="ctr"/>
+                      <a:r>
+                        <a:rPr sz="1100" b="1">
+                          <a:solidFill>
+                            <a:srgbClr val="5B5F6E"/>
+                          </a:solidFill>
+                          <a:latin typeface="Calibri"/>
+                        </a:rPr>
+                        <a:t>—</a:t>
+                      </a:r>
+                    </a:p>
+                  </a:txBody>
+                  <a:tcPr>
+                    <a:solidFill>
+                      <a:srgbClr val="F7F8FC"/>
+                    </a:solidFill>
+                  </a:tcPr>
+                </a:tc>
+              </a:tr>
+            </a:tbl>
+          </a:graphicData>
+        </a:graphic>
+      </p:graphicFrame>
+      <p:sp>
+        <p:nvSpPr>
+          <p:cNvPr id="20" name="Rectangle 19"/>
+          <p:cNvSpPr/>
+          <p:nvPr/>
+        </p:nvSpPr>
+        <p:spPr>
+          <a:xfrm>
+            <a:off x="5943600" y="4023360"/>
+            <a:ext cx="292608" cy="292608"/>
+          </a:xfrm>
+          <a:prstGeom prst="rect">
+            <a:avLst/>
+          </a:prstGeom>
+          <a:solidFill>
+            <a:srgbClr val="1E2761"/>
+          </a:solidFill>
+          <a:ln>
+            <a:noFill/>
+          </a:ln>
+        </p:spPr>
+        <p:style>
+          <a:lnRef idx="1">
+            <a:schemeClr val="accent1"/>
+          </a:lnRef>
+          <a:fillRef idx="3">
+            <a:schemeClr val="accent1"/>
+          </a:fillRef>
+          <a:effectRef idx="2">
+            <a:schemeClr val="accent1"/>
+          </a:effectRef>
+          <a:fontRef idx="minor">
+            <a:schemeClr val="lt1"/>
+          </a:fontRef>
+        </p:style>
+        <p:txBody>
+          <a:bodyPr rtlCol="0" anchor="ctr"/>
+          <a:lstStyle/>
+          <a:p/>
+        </p:txBody>
+      </p:sp>
+      <p:sp>
+        <p:nvSpPr>
+          <p:cNvPr id="21" name="TextBox 20"/>
+          <p:cNvSpPr txBox="1"/>
+          <p:nvPr/>
+        </p:nvSpPr>
+        <p:spPr>
+          <a:xfrm>
+            <a:off x="6355080" y="3995928"/>
+            <a:ext cx="5349240" cy="347472"/>
+          </a:xfrm>
+          <a:prstGeom prst="rect">
+            <a:avLst/>
+          </a:prstGeom>
+          <a:noFill/>
+        </p:spPr>
+        <p:txBody>
+          <a:bodyPr wrap="square" lIns="0" rIns="0" tIns="0" bIns="0">
+            <a:spAutoFit/>
+          </a:bodyPr>
+          <a:lstStyle/>
+          <a:p>
+            <a:pPr>
+              <a:spcAft>
+                <a:spcPts val="200"/>
+              </a:spcAft>
+            </a:pPr>
+            <a:r>
+              <a:rPr sz="1500" b="1">
+                <a:solidFill>
+                  <a:srgbClr val="1E2761"/>
+                </a:solidFill>
+                <a:latin typeface="Calibri"/>
+              </a:rPr>
+              <a:t>RESEARCH QUESTION</a:t>
+            </a:r>
+          </a:p>
+        </p:txBody>
+      </p:sp>
+      <p:sp>
+        <p:nvSpPr>
+          <p:cNvPr id="22" name="Rectangle 21"/>
+          <p:cNvSpPr/>
+          <p:nvPr/>
+        </p:nvSpPr>
+        <p:spPr>
+          <a:xfrm>
+            <a:off x="5943600" y="4434840"/>
+            <a:ext cx="5760720" cy="1965960"/>
+          </a:xfrm>
+          <a:prstGeom prst="rect">
+            <a:avLst/>
+          </a:prstGeom>
+          <a:solidFill>
+            <a:srgbClr val="F7F8FC"/>
+          </a:solidFill>
+          <a:ln>
+            <a:noFill/>
+          </a:ln>
+        </p:spPr>
+        <p:style>
+          <a:lnRef idx="1">
+            <a:schemeClr val="accent1"/>
+          </a:lnRef>
+          <a:fillRef idx="3">
+            <a:schemeClr val="accent1"/>
+          </a:fillRef>
+          <a:effectRef idx="2">
+            <a:schemeClr val="accent1"/>
+          </a:effectRef>
+          <a:fontRef idx="minor">
+            <a:schemeClr val="lt1"/>
+          </a:fontRef>
+        </p:style>
+        <p:txBody>
+          <a:bodyPr rtlCol="0" anchor="ctr"/>
+          <a:lstStyle/>
+          <a:p/>
+        </p:txBody>
+      </p:sp>
+      <p:sp>
+        <p:nvSpPr>
+          <p:cNvPr id="23" name="TextBox 22"/>
+          <p:cNvSpPr txBox="1"/>
+          <p:nvPr/>
+        </p:nvSpPr>
+        <p:spPr>
+          <a:xfrm>
+            <a:off x="6217920" y="4572000"/>
+            <a:ext cx="5212080" cy="1737360"/>
+          </a:xfrm>
+          <a:prstGeom prst="rect">
+            <a:avLst/>
+          </a:prstGeom>
+          <a:noFill/>
+        </p:spPr>
+        <p:txBody>
+          <a:bodyPr wrap="square" lIns="0" rIns="0" tIns="0" bIns="0">
+            <a:spAutoFit/>
+          </a:bodyPr>
+          <a:lstStyle/>
+          <a:p>
+            <a:pPr>
+              <a:spcAft>
+                <a:spcPts val="500"/>
+              </a:spcAft>
+            </a:pPr>
+            <a:r>
+              <a:rPr sz="1000" b="0">
+                <a:solidFill>
+                  <a:srgbClr val="5B5F6E"/>
+                </a:solidFill>
+                <a:latin typeface="Calibri"/>
+              </a:rPr>
+              <a:t>Does buyer memory change future behaviour and produce stable buyer–seller relationships over time?</a:t>
+            </a:r>
+          </a:p>
+          <a:p>
+            <a:pPr>
+              <a:spcAft>
+                <a:spcPts val="500"/>
+              </a:spcAft>
+            </a:pPr>
+            <a:r>
+              <a:rPr sz="1000" b="1">
+                <a:solidFill>
+                  <a:srgbClr val="1E2761"/>
+                </a:solidFill>
+                <a:latin typeface="Calibri"/>
+              </a:rPr>
+              <a:t>Finding: </a:t>
+            </a:r>
+            <a:r>
+              <a:rPr sz="1000" b="0">
+                <a:solidFill>
+                  <a:srgbClr val="5B5F6E"/>
+                </a:solidFill>
+                <a:latin typeface="Calibri"/>
+              </a:rPr>
+              <a:t>Yes. Memory raises pair stability from 0.312 to 0.420 against an identical no-loyalty control on the same seeds — +0.109, CI [+0.105, +0.112].</a:t>
+            </a:r>
+          </a:p>
+          <a:p>
+            <a:pPr>
+              <a:spcAft>
+                <a:spcPts val="500"/>
+              </a:spcAft>
+            </a:pPr>
+            <a:r>
+              <a:rPr sz="1000" b="1">
+                <a:solidFill>
+                  <a:srgbClr val="1E2761"/>
+                </a:solidFill>
+                <a:latin typeface="Calibri"/>
+              </a:rPr>
+              <a:t>Caveat: </a:t>
+            </a:r>
+            <a:r>
+              <a:rPr sz="1000" b="0">
+                <a:solidFill>
+                  <a:srgbClr val="5B5F6E"/>
+                </a:solidFill>
+                <a:latin typeface="Calibri"/>
+              </a:rPr>
+              <a:t>The control's own 0.312 is not memory: unequal seller popularity and season-long fixed preference produce most of it, so the raw level must never be read as a loyalty effect. The within-season rise (+0.037) is weak and window-sensitive — it fails at a weeks 1–2 early window, and its window was narrowed post-hoc after the pre-registered one failed. Lead with the control comparison, not the rise.</a:t>
+            </a:r>
+          </a:p>
+        </p:txBody>
+      </p:sp>
+      <p:sp>
+        <p:nvSpPr>
+          <p:cNvPr id="24" name="TextBox 23"/>
+          <p:cNvSpPr txBox="1"/>
+          <p:nvPr/>
+        </p:nvSpPr>
+        <p:spPr>
+          <a:xfrm>
+            <a:off x="457200" y="6446520"/>
+            <a:ext cx="11247120" cy="274320"/>
+          </a:xfrm>
+          <a:prstGeom prst="rect">
+            <a:avLst/>
+          </a:prstGeom>
+          <a:noFill/>
+        </p:spPr>
+        <p:txBody>
+          <a:bodyPr wrap="square" lIns="0" rIns="0" tIns="0" bIns="0">
+            <a:spAutoFit/>
+          </a:bodyPr>
+          <a:lstStyle/>
+          <a:p>
+            <a:pPr>
+              <a:spcAft>
+                <a:spcPts val="200"/>
+              </a:spcAft>
+            </a:pPr>
+            <a:r>
+              <a:rPr sz="950" b="0">
+                <a:solidFill>
+                  <a:srgbClr val="5B5F6E"/>
+                </a:solidFill>
+                <a:latin typeface="Calibri"/>
+              </a:rPr>
+              <a:t>Generated automatically at phase completion  ·  Phase Completion Deliverable  ·  market-sim project</a:t>
+            </a:r>
+          </a:p>
+        </p:txBody>
+      </p:sp>
+    </p:spTree>
+  </p:cSld>
+  <p:clrMapOvr>
+    <a:masterClrMapping/>
+  </p:clrMapOvr>
+</p:sld>
+</file>
+
 <file path=ppt/theme/theme1.xml><?xml version="1.0" encoding="utf-8"?>
 <a:theme xmlns:a="http://schemas.openxmlformats.org/drawingml/2006/main" name="Office Theme">
   <a:themeElements>

</xml_diff>

<commit_message>
Re-run Phases 1-7 under the dispersed population
Every conclusion survives; the numbers move slightly and the Phase 7
landscape changes shape.

  Phase 2 stratification  +0.088 CI [+0.053, +0.124]   was +0.076
  price sensitivity share      27%                     was 22%
  Phase 5 additive        equivalent, rolls back       unchanged
  Phase 6 memory effect   +0.1087 CI [+0.105, +0.112]  was +0.1086
  Phase 7 Slow optimum    2.65, interior, smooth       was 3.00, a cliff

Phase 1 is untouched, as it configures no dispersion: participation
0.8217 to twelve decimal places, still pinned by its regression test.

15 log rows at 5e077af, none dirty. 207 tests pass.
</commit_message>
<xml_diff>
--- a/project_tracking.pptx
+++ b/project_tracking.pptx
@@ -5500,7 +5500,7 @@
                           </a:solidFill>
                           <a:latin typeface="Calibri"/>
                         </a:rPr>
-                        <a:t>0.818</a:t>
+                        <a:t>0.816</a:t>
                       </a:r>
                     </a:p>
                   </a:txBody>
@@ -5569,7 +5569,7 @@
                           </a:solidFill>
                           <a:latin typeface="Calibri"/>
                         </a:rPr>
-                        <a:t>+0.076</a:t>
+                        <a:t>+0.088</a:t>
                       </a:r>
                     </a:p>
                   </a:txBody>
@@ -5638,7 +5638,7 @@
                           </a:solidFill>
                           <a:latin typeface="Calibri"/>
                         </a:rPr>
-                        <a:t>[+0.04, +0.11]</a:t>
+                        <a:t>[+0.05, +0.12]</a:t>
                       </a:r>
                     </a:p>
                   </a:txBody>
@@ -5707,7 +5707,7 @@
                           </a:solidFill>
                           <a:latin typeface="Calibri"/>
                         </a:rPr>
-                        <a:t>min 57</a:t>
+                        <a:t>min 58</a:t>
                       </a:r>
                     </a:p>
                   </a:txBody>
@@ -5776,7 +5776,7 @@
                           </a:solidFill>
                           <a:latin typeface="Calibri"/>
                         </a:rPr>
-                        <a:t>0.239</a:t>
+                        <a:t>0.232</a:t>
                       </a:r>
                     </a:p>
                   </a:txBody>
@@ -6063,7 +6063,7 @@
                 </a:solidFill>
                 <a:latin typeface="Calibri"/>
               </a:rPr>
-              <a:t>Yes, but mostly through budgets. Richer buyers reach the premium tier more than poorer ones (+0.076, CI excludes 0), and all 3 graded criteria pass.</a:t>
+              <a:t>Yes, but mostly through budgets. Richer buyers reach the premium tier more than poorer ones (+0.088, CI excludes 0), and all 3 graded criteria pass.</a:t>
             </a:r>
           </a:p>
           <a:p>
@@ -6088,7 +6088,7 @@
                 </a:solidFill>
                 <a:latin typeface="Calibri"/>
               </a:rPr>
-              <a:t>Only ~22% of the gap is price sensitivity: equalizing α across classes leaves +0.059 of it standing, so budget heterogeneity does the rest. Poor's 0.000 Shigh share is an affordability wall (budget 3 &lt; price 6), unchanged by any α, and is not evidence for the price-sensitivity mechanism.</a:t>
+              <a:t>Only ~27% of the gap is price sensitivity: equalizing α across classes leaves +0.065 of it standing, so budget heterogeneity does the rest. Poor's 0.000 Shigh share is an affordability wall (budget 3 &lt; price 6), unchanged by any α, and is not evidence for the price-sensitivity mechanism.</a:t>
             </a:r>
           </a:p>
         </p:txBody>
@@ -7037,7 +7037,7 @@
                           </a:solidFill>
                           <a:latin typeface="Calibri"/>
                         </a:rPr>
-                        <a:t>0.753</a:t>
+                        <a:t>0.752</a:t>
                       </a:r>
                     </a:p>
                   </a:txBody>
@@ -7106,7 +7106,7 @@
                           </a:solidFill>
                           <a:latin typeface="Calibri"/>
                         </a:rPr>
-                        <a:t>+8.67</a:t>
+                        <a:t>+8.53</a:t>
                       </a:r>
                     </a:p>
                   </a:txBody>
@@ -7175,7 +7175,7 @@
                           </a:solidFill>
                           <a:latin typeface="Calibri"/>
                         </a:rPr>
-                        <a:t>+1.97</a:t>
+                        <a:t>+2.13</a:t>
                       </a:r>
                     </a:p>
                   </a:txBody>
@@ -7531,7 +7531,7 @@
                 </a:solidFill>
                 <a:latin typeface="Calibri"/>
               </a:rPr>
-              <a:t>It changes which seller, not which tier. Near stalls outsell far ones in both tiers, while class-to-tier sorting is statistically unmoved (every shift's 95% CI contains zero, none wider than ±0.027).</a:t>
+              <a:t>It changes which seller, not which tier. Near stalls outsell far ones in both tiers, while class-to-tier sorting is statistically unmoved (every shift's 95% CI contains zero, none wider than ±0.032).</a:t>
             </a:r>
           </a:p>
           <a:p>
@@ -7556,7 +7556,7 @@
                 </a:solidFill>
                 <a:latin typeface="Calibri"/>
               </a:rPr>
-              <a:t>The null share shift is a pre-registered valid outcome, not a failure. The phase's largest effect is ungraded: participation falls -0.065 (CI [-0.074, -0.057]) because unnoticed stalls cannot be bought from. Note also that this position assignment gives Slow a tier-level visibility edge (0.850 vs 0.775), so a different assignment would move tier shares differently.</a:t>
+              <a:t>The null share shift is a pre-registered valid outcome, not a failure. The phase's largest effect is ungraded: participation falls -0.065 (CI [-0.073, -0.056]) because unnoticed stalls cannot be bought from. Note also that this position assignment gives Slow a tier-level visibility edge (0.850 vs 0.775), so a different assignment would move tier shares differently.</a:t>
             </a:r>
           </a:p>
         </p:txBody>
@@ -8505,7 +8505,7 @@
                           </a:solidFill>
                           <a:latin typeface="Calibri"/>
                         </a:rPr>
-                        <a:t>0.753</a:t>
+                        <a:t>0.752</a:t>
                       </a:r>
                     </a:p>
                   </a:txBody>
@@ -8574,7 +8574,7 @@
                           </a:solidFill>
                           <a:latin typeface="Calibri"/>
                         </a:rPr>
-                        <a:t>+1.13 to +2.93</a:t>
+                        <a:t>+1.97 to +3.37</a:t>
                       </a:r>
                     </a:p>
                   </a:txBody>
@@ -8643,7 +8643,7 @@
                           </a:solidFill>
                           <a:latin typeface="Calibri"/>
                         </a:rPr>
-                        <a:t>+1.37 vs +0.20</a:t>
+                        <a:t>+2.57 vs +0.43</a:t>
                       </a:r>
                     </a:p>
                   </a:txBody>
@@ -8712,7 +8712,7 @@
                           </a:solidFill>
                           <a:latin typeface="Calibri"/>
                         </a:rPr>
-                        <a:t>+2.87 vs +0.07</a:t>
+                        <a:t>+2.50 vs +0.43</a:t>
                       </a:r>
                     </a:p>
                   </a:txBody>
@@ -8999,7 +8999,7 @@
                 </a:solidFill>
                 <a:latin typeface="Calibri"/>
               </a:rPr>
-              <a:t>An interaction, decisively. Lift concentrates in the lowest-budget class that can afford the discounted stall — Poor at Slow (+1.37 vs +0.03 for Rich), Middle at Shigh (+2.87 vs +0.07). Both responders were predicted from the parameters before the runs.</a:t>
+              <a:t>An interaction, decisively. Lift concentrates in the lowest-budget class that can afford the discounted stall — Poor at Slow (+2.57 vs +0.37 for Rich), Middle at Shigh (+2.50 vs +0.43). Both responders were predicted from the parameters before the runs.</a:t>
             </a:r>
           </a:p>
           <a:p>
@@ -9024,7 +9024,7 @@
                 </a:solidFill>
                 <a:latin typeface="Calibri"/>
               </a:rPr>
-              <a:t>The specified 0.2 lottery cannot measure this: it fired 6 times in 30 runs, distributed [4, 0, 0, 1, 1], leaving sellers never promoted at all. Criteria are graded on paired forced arms instead; the lottery is kept as the market Phase 5 inherits. Poor's +0.00 at a promoted Shigh stall is arithmetic — 6 × 0.7 = 4.2 still exceeds its budget of 3 — not insensitivity to promotions.</a:t>
+              <a:t>The specified 0.2 lottery cannot measure this: it fired 6 times in 30 runs, distributed [4, 0, 0, 1, 1], leaving sellers never promoted at all. Criteria are graded on paired forced arms instead; the lottery is kept as the market Phase 5 inherits. Poor's +0.03 at a promoted Shigh stall is arithmetic — 6 × 0.7 = 4.2 still exceeds its budget of 3 — not insensitivity to promotions.</a:t>
             </a:r>
           </a:p>
         </p:txBody>
@@ -9973,7 +9973,7 @@
                           </a:solidFill>
                           <a:latin typeface="Calibri"/>
                         </a:rPr>
-                        <a:t>0.753</a:t>
+                        <a:t>0.739</a:t>
                       </a:r>
                     </a:p>
                   </a:txBody>
@@ -10042,7 +10042,7 @@
                           </a:solidFill>
                           <a:latin typeface="Calibri"/>
                         </a:rPr>
-                        <a:t>+0.17 pp</a:t>
+                        <a:t>-1.64 pp</a:t>
                       </a:r>
                     </a:p>
                   </a:txBody>
@@ -10111,7 +10111,7 @@
                           </a:solidFill>
                           <a:latin typeface="Calibri"/>
                         </a:rPr>
-                        <a:t>[-0.9, +1.3]</a:t>
+                        <a:t>[-2.4, -0.9]</a:t>
                       </a:r>
                     </a:p>
                   </a:txBody>
@@ -10180,7 +10180,7 @@
                           </a:solidFill>
                           <a:latin typeface="Calibri"/>
                         </a:rPr>
-                        <a:t>-2.73 pp</a:t>
+                        <a:t>+1.78 pp</a:t>
                       </a:r>
                     </a:p>
                   </a:txBody>
@@ -10249,7 +10249,7 @@
                           </a:solidFill>
                           <a:latin typeface="Calibri"/>
                         </a:rPr>
-                        <a:t>17/2677 (0.6%)</a:t>
+                        <a:t>111/2656 (4.2%)</a:t>
                       </a:r>
                     </a:p>
                   </a:txBody>
@@ -10492,7 +10492,7 @@
                 </a:solidFill>
                 <a:latin typeface="Calibri"/>
               </a:rPr>
-              <a:t>The cliff cannot fire on any buyer's first purchase at these parameters (smallest first-purchase gap is 1.0 against a 0.5 threshold), so it reached only 0.6% of purchases. That is why the effect is small here, not evidence that threshold effects are unimportant. The cliff-only arm was undecided at 30 seeds — point estimate 4.68 pp with a CI reaching 6.36 — and needed 1000 seeds to settle at -2.73 pp.</a:t>
+              <a:t>The cliff cannot fire on any buyer's first purchase at these parameters (smallest first-purchase gap is 1.0 against a 0.5 threshold), so it reached only 4.2% of purchases. That is why the effect is small here, not evidence that threshold effects are unimportant. The cliff-only arm was undecided at 30 seeds — point estimate 4.68 pp with a CI reaching 6.36 — and needed 1000 seeds to settle at +1.78 pp.</a:t>
             </a:r>
           </a:p>
         </p:txBody>
@@ -11441,7 +11441,7 @@
                           </a:solidFill>
                           <a:latin typeface="Calibri"/>
                         </a:rPr>
-                        <a:t>0.693</a:t>
+                        <a:t>0.692</a:t>
                       </a:r>
                     </a:p>
                   </a:txBody>
@@ -11717,7 +11717,7 @@
                           </a:solidFill>
                           <a:latin typeface="Calibri"/>
                         </a:rPr>
-                        <a:t>+0.037</a:t>
+                        <a:t>+0.042</a:t>
                       </a:r>
                     </a:p>
                   </a:txBody>
@@ -11786,7 +11786,7 @@
                           </a:solidFill>
                           <a:latin typeface="Calibri"/>
                         </a:rPr>
-                        <a:t>week 14</a:t>
+                        <a:t>week 15</a:t>
                       </a:r>
                     </a:p>
                   </a:txBody>
@@ -12004,7 +12004,7 @@
                 </a:solidFill>
                 <a:latin typeface="Calibri"/>
               </a:rPr>
-              <a:t>Yes. Memory raises pair stability from 0.312 to 0.420 against an identical no-loyalty control on the same seeds — +0.109, CI [+0.105, +0.112].</a:t>
+              <a:t>Yes. Memory raises pair stability from 0.316 to 0.425 against an identical no-loyalty control on the same seeds — +0.109, CI [+0.105, +0.112].</a:t>
             </a:r>
           </a:p>
           <a:p>
@@ -12029,7 +12029,7 @@
                 </a:solidFill>
                 <a:latin typeface="Calibri"/>
               </a:rPr>
-              <a:t>The control's own 0.312 is not memory: unequal seller popularity and season-long fixed preference produce most of it, so the raw level must never be read as a loyalty effect. The within-season rise (+0.037) is weak and window-sensitive — it fails at a weeks 1–2 early window, and its window was narrowed post-hoc after the pre-registered one failed. Lead with the control comparison, not the rise.</a:t>
+              <a:t>The control's own 0.316 is not memory: unequal seller popularity and season-long fixed preference produce most of it, so the raw level must never be read as a loyalty effect. The within-season rise (+0.042) is weak and window-sensitive — it fails at a weeks 1–2 early window, and its window was narrowed post-hoc after the pre-registered one failed. Lead with the control comparison, not the rise.</a:t>
             </a:r>
           </a:p>
         </p:txBody>
@@ -12978,7 +12978,7 @@
                           </a:solidFill>
                           <a:latin typeface="Calibri"/>
                         </a:rPr>
-                        <a:t>0.688</a:t>
+                        <a:t>0.679</a:t>
                       </a:r>
                     </a:p>
                   </a:txBody>
@@ -13047,7 +13047,7 @@
                           </a:solidFill>
                           <a:latin typeface="Calibri"/>
                         </a:rPr>
-                        <a:t>0.71–1.51×</a:t>
+                        <a:t>0.75–1.51×</a:t>
                       </a:r>
                     </a:p>
                   </a:txBody>
@@ -13116,7 +13116,7 @@
                           </a:solidFill>
                           <a:latin typeface="Calibri"/>
                         </a:rPr>
-                        <a:t>4.08 vs 3</a:t>
+                        <a:t>4.26 vs 3</a:t>
                       </a:r>
                     </a:p>
                   </a:txBody>
@@ -13185,7 +13185,7 @@
                           </a:solidFill>
                           <a:latin typeface="Calibri"/>
                         </a:rPr>
-                        <a:t>49.5 → 64.3</a:t>
+                        <a:t>48.4 → 60.9</a:t>
                       </a:r>
                     </a:p>
                   </a:txBody>
@@ -13254,7 +13254,7 @@
                           </a:solidFill>
                           <a:latin typeface="Calibri"/>
                         </a:rPr>
-                        <a:t>[+12.5, +17.1]</a:t>
+                        <a:t>[+10.6, +14.5]</a:t>
                       </a:r>
                     </a:p>
                   </a:txBody>
@@ -13323,7 +13323,7 @@
                           </a:solidFill>
                           <a:latin typeface="Calibri"/>
                         </a:rPr>
-                        <a:t>2.37</a:t>
+                        <a:t>2.34</a:t>
                       </a:r>
                     </a:p>
                   </a:txBody>
@@ -13541,7 +13541,7 @@
                 </a:solidFill>
                 <a:latin typeface="Calibri"/>
               </a:rPr>
-              <a:t>A non-learning heuristic already captures +14.8 profit per week over fixed pricing, CI [+12.5, +17.1], and stops at 2.37 — short of the 3.00 optimum. That gap is what 7b–7d have to win.</a:t>
+              <a:t>A non-learning heuristic already captures +12.5 profit per week over fixed pricing, CI [+10.6, +14.5], and stops at 2.34 — short of the 3.00 optimum. That gap is what 7b–7d have to win.</a:t>
             </a:r>
           </a:p>
           <a:p>
@@ -14515,7 +14515,7 @@
                           </a:solidFill>
                           <a:latin typeface="Calibri"/>
                         </a:rPr>
-                        <a:t>+6.6%</a:t>
+                        <a:t>+7.9%</a:t>
                       </a:r>
                     </a:p>
                   </a:txBody>
@@ -14584,7 +14584,7 @@
                           </a:solidFill>
                           <a:latin typeface="Calibri"/>
                         </a:rPr>
-                        <a:t>[+5.9%, +7.4%]</a:t>
+                        <a:t>[+7.2%, +8.5%]</a:t>
                       </a:r>
                     </a:p>
                   </a:txBody>
@@ -14653,7 +14653,7 @@
                           </a:solidFill>
                           <a:latin typeface="Calibri"/>
                         </a:rPr>
-                        <a:t>+10.3%</a:t>
+                        <a:t>+11.2%</a:t>
                       </a:r>
                     </a:p>
                   </a:txBody>
@@ -14722,7 +14722,7 @@
                           </a:solidFill>
                           <a:latin typeface="Calibri"/>
                         </a:rPr>
-                        <a:t>[+9.5%, +11.0%]</a:t>
+                        <a:t>[+10.5%, +11.9%]</a:t>
                       </a:r>
                     </a:p>
                   </a:txBody>
@@ -14860,7 +14860,7 @@
                           </a:solidFill>
                           <a:latin typeface="Calibri"/>
                         </a:rPr>
-                        <a:t>2.37 vs ceiling 2.40</a:t>
+                        <a:t>2.36 vs ceiling 2.40</a:t>
                       </a:r>
                     </a:p>
                   </a:txBody>
@@ -15078,7 +15078,7 @@
                 </a:solidFill>
                 <a:latin typeface="Calibri"/>
               </a:rPr>
-              <a:t>Yes on profit, no on structure. Both algorithms clear the ±5% margin — ε-greedy +6.6%, UCB1 +10.3% — while every class-to-tier share stays equivalent to 7a. Myopic optimization raises the seller's own profit without changing the market.</a:t>
+              <a:t>Yes on profit, no on structure. Both algorithms clear the ±5% margin — ε-greedy +7.9%, UCB1 +11.2% — while every class-to-tier share stays equivalent to 7a. Myopic optimization raises the seller's own profit without changing the market.</a:t>
             </a:r>
           </a:p>
           <a:p>
@@ -15103,7 +15103,7 @@
                 </a:solidFill>
                 <a:latin typeface="Calibri"/>
               </a:rPr>
-              <a:t>The bandit stops at 2.37, its arm ceiling, while the profit optimum is 3.00 — exactly Poor's budget. Its binding limit is the fixed local hypothesis space, not the learning rule, and widening the arms to reach the optimum would encode the answer. What moved the result was initialization, not the algorithm: without an initial sweep ε-greedy swings 12.8/week and appears to lose to 7a.</a:t>
+              <a:t>The bandit stops at 2.36, its arm ceiling, while the profit optimum is 3.00 — exactly Poor's budget. Its binding limit is the fixed local hypothesis space, not the learning rule, and widening the arms to reach the optimum would encode the answer. What moved the result was initialization, not the algorithm: without an initial sweep ε-greedy swings 12.8/week and appears to lose to 7a.</a:t>
             </a:r>
           </a:p>
         </p:txBody>

</xml_diff>

<commit_message>
Phase 7d results, slide, and a ROADMAP brought up to date
17 log rows at 1419242, none dirty. Nine slides.

The ROADMAP's current-phase marker still said Phase 6 and the phase list
still described Phase 7 as an open question. Both now record what Phase 7
actually found: the headline question answered in the negative twice, and
both nulls tracing to loyalty_streak_cap = 3 - a bounded counter is not a
stock, so there is neither cross-sectional state worth conditioning on
nor an intertemporal asset worth investing in.

Phase 7e is added to the phase list as the turn from obstacle to
question: under what market structure does each level of policy
complexity become necessary? It is a separate environment, so the base
environment's results stand alongside it rather than being replaced.
</commit_message>
<xml_diff>
--- a/project_tracking.pptx
+++ b/project_tracking.pptx
@@ -13,6 +13,7 @@
     <p:sldId id="261" r:id="rId12"/>
     <p:sldId id="262" r:id="rId13"/>
     <p:sldId id="263" r:id="rId14"/>
+    <p:sldId id="264" r:id="rId15"/>
   </p:sldIdLst>
   <p:sldSz cx="12191969" cy="6858000" type="screen4x3"/>
   <p:notesSz cx="6858000" cy="9144000"/>
@@ -15104,6 +15105,1543 @@
                 <a:latin typeface="Calibri"/>
               </a:rPr>
               <a:t>The bandit stops at 2.36, its arm ceiling, while the profit optimum is 3.00 — exactly Poor's budget. Its binding limit is the fixed local hypothesis space, not the learning rule, and widening the arms to reach the optimum would encode the answer. What moved the result was initialization, not the algorithm: without an initial sweep ε-greedy swings 12.8/week and appears to lose to 7a.</a:t>
+            </a:r>
+          </a:p>
+        </p:txBody>
+      </p:sp>
+      <p:sp>
+        <p:nvSpPr>
+          <p:cNvPr id="24" name="TextBox 23"/>
+          <p:cNvSpPr txBox="1"/>
+          <p:nvPr/>
+        </p:nvSpPr>
+        <p:spPr>
+          <a:xfrm>
+            <a:off x="457200" y="6446520"/>
+            <a:ext cx="11247120" cy="274320"/>
+          </a:xfrm>
+          <a:prstGeom prst="rect">
+            <a:avLst/>
+          </a:prstGeom>
+          <a:noFill/>
+        </p:spPr>
+        <p:txBody>
+          <a:bodyPr wrap="square" lIns="0" rIns="0" tIns="0" bIns="0">
+            <a:spAutoFit/>
+          </a:bodyPr>
+          <a:lstStyle/>
+          <a:p>
+            <a:pPr>
+              <a:spcAft>
+                <a:spcPts val="200"/>
+              </a:spcAft>
+            </a:pPr>
+            <a:r>
+              <a:rPr sz="950" b="0">
+                <a:solidFill>
+                  <a:srgbClr val="5B5F6E"/>
+                </a:solidFill>
+                <a:latin typeface="Calibri"/>
+              </a:rPr>
+              <a:t>Generated automatically at phase completion  ·  Phase Completion Deliverable  ·  market-sim project</a:t>
+            </a:r>
+          </a:p>
+        </p:txBody>
+      </p:sp>
+    </p:spTree>
+  </p:cSld>
+  <p:clrMapOvr>
+    <a:masterClrMapping/>
+  </p:clrMapOvr>
+</p:sld>
+</file>
+
+<file path=ppt/slides/slide9.xml><?xml version="1.0" encoding="utf-8"?>
+<p:sld xmlns:a="http://schemas.openxmlformats.org/drawingml/2006/main" xmlns:p="http://schemas.openxmlformats.org/presentationml/2006/main" xmlns:r="http://schemas.openxmlformats.org/officeDocument/2006/relationships">
+  <p:cSld>
+    <p:spTree>
+      <p:nvGrpSpPr>
+        <p:cNvPr id="1" name=""/>
+        <p:cNvGrpSpPr/>
+        <p:nvPr/>
+      </p:nvGrpSpPr>
+      <p:grpSpPr/>
+      <p:sp>
+        <p:nvSpPr>
+          <p:cNvPr id="2" name="TextBox 1"/>
+          <p:cNvSpPr txBox="1"/>
+          <p:nvPr/>
+        </p:nvSpPr>
+        <p:spPr>
+          <a:xfrm>
+            <a:off x="457200" y="320040"/>
+            <a:ext cx="8229600" cy="548640"/>
+          </a:xfrm>
+          <a:prstGeom prst="rect">
+            <a:avLst/>
+          </a:prstGeom>
+          <a:noFill/>
+        </p:spPr>
+        <p:txBody>
+          <a:bodyPr wrap="square" lIns="0" rIns="0" tIns="0" bIns="0">
+            <a:spAutoFit/>
+          </a:bodyPr>
+          <a:lstStyle/>
+          <a:p>
+            <a:pPr>
+              <a:spcAft>
+                <a:spcPts val="200"/>
+              </a:spcAft>
+            </a:pPr>
+            <a:r>
+              <a:rPr sz="3200" b="1">
+                <a:solidFill>
+                  <a:srgbClr val="1E2761"/>
+                </a:solidFill>
+                <a:latin typeface="Cambria"/>
+              </a:rPr>
+              <a:t>Phase 7 — Seller Learning — 7d Reinforcement Learning</a:t>
+            </a:r>
+          </a:p>
+        </p:txBody>
+      </p:sp>
+      <p:sp>
+        <p:nvSpPr>
+          <p:cNvPr id="3" name="TextBox 2"/>
+          <p:cNvSpPr txBox="1"/>
+          <p:nvPr/>
+        </p:nvSpPr>
+        <p:spPr>
+          <a:xfrm>
+            <a:off x="457200" y="868680"/>
+            <a:ext cx="8229600" cy="274320"/>
+          </a:xfrm>
+          <a:prstGeom prst="rect">
+            <a:avLst/>
+          </a:prstGeom>
+          <a:noFill/>
+        </p:spPr>
+        <p:txBody>
+          <a:bodyPr wrap="square" lIns="0" rIns="0" tIns="0" bIns="0">
+            <a:spAutoFit/>
+          </a:bodyPr>
+          <a:lstStyle/>
+          <a:p>
+            <a:pPr>
+              <a:spcAft>
+                <a:spcPts val="200"/>
+              </a:spcAft>
+            </a:pPr>
+            <a:r>
+              <a:rPr sz="1200" b="0">
+                <a:solidFill>
+                  <a:srgbClr val="5B5F6E"/>
+                </a:solidFill>
+                <a:latin typeface="Calibri"/>
+              </a:rPr>
+              <a:t>Multi-week return vs the myopic bandit  ·  git tag: phase7d-validated  ·  train 1000–1119, evaluate 0–29</a:t>
+            </a:r>
+          </a:p>
+        </p:txBody>
+      </p:sp>
+      <p:sp>
+        <p:nvSpPr>
+          <p:cNvPr id="4" name="Rounded Rectangle 3"/>
+          <p:cNvSpPr/>
+          <p:nvPr/>
+        </p:nvSpPr>
+        <p:spPr>
+          <a:xfrm>
+            <a:off x="9464040" y="365760"/>
+            <a:ext cx="2240280" cy="384048"/>
+          </a:xfrm>
+          <a:prstGeom prst="roundRect">
+            <a:avLst/>
+          </a:prstGeom>
+          <a:solidFill>
+            <a:srgbClr val="C9922E"/>
+          </a:solidFill>
+          <a:ln>
+            <a:noFill/>
+          </a:ln>
+        </p:spPr>
+        <p:style>
+          <a:lnRef idx="1">
+            <a:schemeClr val="accent1"/>
+          </a:lnRef>
+          <a:fillRef idx="3">
+            <a:schemeClr val="accent1"/>
+          </a:fillRef>
+          <a:effectRef idx="2">
+            <a:schemeClr val="accent1"/>
+          </a:effectRef>
+          <a:fontRef idx="minor">
+            <a:schemeClr val="lt1"/>
+          </a:fontRef>
+        </p:style>
+        <p:txBody>
+          <a:bodyPr rtlCol="0" anchor="ctr"/>
+          <a:lstStyle/>
+          <a:p>
+            <a:pPr algn="ctr"/>
+            <a:r>
+              <a:rPr sz="1050" b="1">
+                <a:solidFill>
+                  <a:srgbClr val="FFFFFF"/>
+                </a:solidFill>
+                <a:latin typeface="Calibri"/>
+              </a:rPr>
+              <a:t>NULL — STOP AT 7b</a:t>
+            </a:r>
+          </a:p>
+        </p:txBody>
+      </p:sp>
+      <p:sp>
+        <p:nvSpPr>
+          <p:cNvPr id="5" name="Rectangle 4"/>
+          <p:cNvSpPr/>
+          <p:nvPr/>
+        </p:nvSpPr>
+        <p:spPr>
+          <a:xfrm>
+            <a:off x="457200" y="1417320"/>
+            <a:ext cx="292608" cy="292608"/>
+          </a:xfrm>
+          <a:prstGeom prst="rect">
+            <a:avLst/>
+          </a:prstGeom>
+          <a:solidFill>
+            <a:srgbClr val="1E2761"/>
+          </a:solidFill>
+          <a:ln>
+            <a:noFill/>
+          </a:ln>
+        </p:spPr>
+        <p:style>
+          <a:lnRef idx="1">
+            <a:schemeClr val="accent1"/>
+          </a:lnRef>
+          <a:fillRef idx="3">
+            <a:schemeClr val="accent1"/>
+          </a:fillRef>
+          <a:effectRef idx="2">
+            <a:schemeClr val="accent1"/>
+          </a:effectRef>
+          <a:fontRef idx="minor">
+            <a:schemeClr val="lt1"/>
+          </a:fontRef>
+        </p:style>
+        <p:txBody>
+          <a:bodyPr rtlCol="0" anchor="ctr"/>
+          <a:lstStyle/>
+          <a:p/>
+        </p:txBody>
+      </p:sp>
+      <p:sp>
+        <p:nvSpPr>
+          <p:cNvPr id="6" name="TextBox 5"/>
+          <p:cNvSpPr txBox="1"/>
+          <p:nvPr/>
+        </p:nvSpPr>
+        <p:spPr>
+          <a:xfrm>
+            <a:off x="868680" y="1389888"/>
+            <a:ext cx="4617720" cy="347472"/>
+          </a:xfrm>
+          <a:prstGeom prst="rect">
+            <a:avLst/>
+          </a:prstGeom>
+          <a:noFill/>
+        </p:spPr>
+        <p:txBody>
+          <a:bodyPr wrap="square" lIns="0" rIns="0" tIns="0" bIns="0">
+            <a:spAutoFit/>
+          </a:bodyPr>
+          <a:lstStyle/>
+          <a:p>
+            <a:pPr>
+              <a:spcAft>
+                <a:spcPts val="200"/>
+              </a:spcAft>
+            </a:pPr>
+            <a:r>
+              <a:rPr sz="1500" b="1">
+                <a:solidFill>
+                  <a:srgbClr val="1E2761"/>
+                </a:solidFill>
+                <a:latin typeface="Calibri"/>
+              </a:rPr>
+              <a:t>AGENTS</a:t>
+            </a:r>
+          </a:p>
+        </p:txBody>
+      </p:sp>
+      <p:sp>
+        <p:nvSpPr>
+          <p:cNvPr id="7" name="TextBox 6"/>
+          <p:cNvSpPr txBox="1"/>
+          <p:nvPr/>
+        </p:nvSpPr>
+        <p:spPr>
+          <a:xfrm>
+            <a:off x="868680" y="1828800"/>
+            <a:ext cx="4617720" cy="566928"/>
+          </a:xfrm>
+          <a:prstGeom prst="rect">
+            <a:avLst/>
+          </a:prstGeom>
+          <a:noFill/>
+        </p:spPr>
+        <p:txBody>
+          <a:bodyPr wrap="square" lIns="0" rIns="0" tIns="0" bIns="0">
+            <a:spAutoFit/>
+          </a:bodyPr>
+          <a:lstStyle/>
+          <a:p>
+            <a:pPr>
+              <a:spcAft>
+                <a:spcPts val="200"/>
+              </a:spcAft>
+            </a:pPr>
+            <a:r>
+              <a:rPr sz="1300" b="1">
+                <a:solidFill>
+                  <a:srgbClr val="1E2761"/>
+                </a:solidFill>
+                <a:latin typeface="Calibri"/>
+              </a:rPr>
+              <a:t>Buyers: </a:t>
+            </a:r>
+            <a:r>
+              <a:rPr sz="1300" b="0">
+                <a:solidFill>
+                  <a:srgbClr val="5B5F6E"/>
+                </a:solidFill>
+                <a:latin typeface="Calibri"/>
+              </a:rPr>
+              <a:t>100 — Poor 70 / Middle 20 / Rich 10, dispersed budgets</a:t>
+            </a:r>
+          </a:p>
+          <a:p>
+            <a:pPr>
+              <a:spcAft>
+                <a:spcPts val="200"/>
+              </a:spcAft>
+            </a:pPr>
+            <a:r>
+              <a:rPr sz="1300" b="1">
+                <a:solidFill>
+                  <a:srgbClr val="1E2761"/>
+                </a:solidFill>
+                <a:latin typeface="Calibri"/>
+              </a:rPr>
+              <a:t>Sellers: </a:t>
+            </a:r>
+            <a:r>
+              <a:rPr sz="1300" b="0">
+                <a:solidFill>
+                  <a:srgbClr val="5B5F6E"/>
+                </a:solidFill>
+                <a:latin typeface="Calibri"/>
+              </a:rPr>
+              <a:t>5 — same arms and costs as 7b, so only the horizon differs</a:t>
+            </a:r>
+          </a:p>
+        </p:txBody>
+      </p:sp>
+      <p:sp>
+        <p:nvSpPr>
+          <p:cNvPr id="8" name="Rectangle 7"/>
+          <p:cNvSpPr/>
+          <p:nvPr/>
+        </p:nvSpPr>
+        <p:spPr>
+          <a:xfrm>
+            <a:off x="457200" y="2651760"/>
+            <a:ext cx="292608" cy="292608"/>
+          </a:xfrm>
+          <a:prstGeom prst="rect">
+            <a:avLst/>
+          </a:prstGeom>
+          <a:solidFill>
+            <a:srgbClr val="1E2761"/>
+          </a:solidFill>
+          <a:ln>
+            <a:noFill/>
+          </a:ln>
+        </p:spPr>
+        <p:style>
+          <a:lnRef idx="1">
+            <a:schemeClr val="accent1"/>
+          </a:lnRef>
+          <a:fillRef idx="3">
+            <a:schemeClr val="accent1"/>
+          </a:fillRef>
+          <a:effectRef idx="2">
+            <a:schemeClr val="accent1"/>
+          </a:effectRef>
+          <a:fontRef idx="minor">
+            <a:schemeClr val="lt1"/>
+          </a:fontRef>
+        </p:style>
+        <p:txBody>
+          <a:bodyPr rtlCol="0" anchor="ctr"/>
+          <a:lstStyle/>
+          <a:p/>
+        </p:txBody>
+      </p:sp>
+      <p:sp>
+        <p:nvSpPr>
+          <p:cNvPr id="9" name="TextBox 8"/>
+          <p:cNvSpPr txBox="1"/>
+          <p:nvPr/>
+        </p:nvSpPr>
+        <p:spPr>
+          <a:xfrm>
+            <a:off x="868680" y="2624328"/>
+            <a:ext cx="4617720" cy="347472"/>
+          </a:xfrm>
+          <a:prstGeom prst="rect">
+            <a:avLst/>
+          </a:prstGeom>
+          <a:noFill/>
+        </p:spPr>
+        <p:txBody>
+          <a:bodyPr wrap="square" lIns="0" rIns="0" tIns="0" bIns="0">
+            <a:spAutoFit/>
+          </a:bodyPr>
+          <a:lstStyle/>
+          <a:p>
+            <a:pPr>
+              <a:spcAft>
+                <a:spcPts val="200"/>
+              </a:spcAft>
+            </a:pPr>
+            <a:r>
+              <a:rPr sz="1500" b="1">
+                <a:solidFill>
+                  <a:srgbClr val="1E2761"/>
+                </a:solidFill>
+                <a:latin typeface="Calibri"/>
+              </a:rPr>
+              <a:t>ENVIRONMENT &amp; CONTEXT</a:t>
+            </a:r>
+          </a:p>
+        </p:txBody>
+      </p:sp>
+      <p:sp>
+        <p:nvSpPr>
+          <p:cNvPr id="10" name="TextBox 9"/>
+          <p:cNvSpPr txBox="1"/>
+          <p:nvPr/>
+        </p:nvSpPr>
+        <p:spPr>
+          <a:xfrm>
+            <a:off x="868680" y="3063240"/>
+            <a:ext cx="4617720" cy="548640"/>
+          </a:xfrm>
+          <a:prstGeom prst="rect">
+            <a:avLst/>
+          </a:prstGeom>
+          <a:noFill/>
+        </p:spPr>
+        <p:txBody>
+          <a:bodyPr wrap="square" lIns="0" rIns="0" tIns="0" bIns="0">
+            <a:spAutoFit/>
+          </a:bodyPr>
+          <a:lstStyle/>
+          <a:p>
+            <a:pPr>
+              <a:spcAft>
+                <a:spcPts val="200"/>
+              </a:spcAft>
+            </a:pPr>
+            <a:r>
+              <a:rPr sz="1300" b="0">
+                <a:solidFill>
+                  <a:srgbClr val="5B5F6E"/>
+                </a:solidFill>
+                <a:latin typeface="Calibri"/>
+              </a:rPr>
+              <a:t>-  66 weeks. Loyalty is a 3-week capped counter that resets on a switch.</a:t>
+            </a:r>
+          </a:p>
+          <a:p>
+            <a:pPr>
+              <a:spcAft>
+                <a:spcPts val="200"/>
+              </a:spcAft>
+            </a:pPr>
+            <a:r>
+              <a:rPr sz="1300" b="0">
+                <a:solidFill>
+                  <a:srgbClr val="5B5F6E"/>
+                </a:solidFill>
+                <a:latin typeface="Calibri"/>
+              </a:rPr>
+              <a:t>-  7c skipped: no external market state predicts which arm is best.</a:t>
+            </a:r>
+          </a:p>
+        </p:txBody>
+      </p:sp>
+      <p:sp>
+        <p:nvSpPr>
+          <p:cNvPr id="11" name="Rectangle 10"/>
+          <p:cNvSpPr/>
+          <p:nvPr/>
+        </p:nvSpPr>
+        <p:spPr>
+          <a:xfrm>
+            <a:off x="457200" y="3886200"/>
+            <a:ext cx="292608" cy="292608"/>
+          </a:xfrm>
+          <a:prstGeom prst="rect">
+            <a:avLst/>
+          </a:prstGeom>
+          <a:solidFill>
+            <a:srgbClr val="1E2761"/>
+          </a:solidFill>
+          <a:ln>
+            <a:noFill/>
+          </a:ln>
+        </p:spPr>
+        <p:style>
+          <a:lnRef idx="1">
+            <a:schemeClr val="accent1"/>
+          </a:lnRef>
+          <a:fillRef idx="3">
+            <a:schemeClr val="accent1"/>
+          </a:fillRef>
+          <a:effectRef idx="2">
+            <a:schemeClr val="accent1"/>
+          </a:effectRef>
+          <a:fontRef idx="minor">
+            <a:schemeClr val="lt1"/>
+          </a:fontRef>
+        </p:style>
+        <p:txBody>
+          <a:bodyPr rtlCol="0" anchor="ctr"/>
+          <a:lstStyle/>
+          <a:p/>
+        </p:txBody>
+      </p:sp>
+      <p:sp>
+        <p:nvSpPr>
+          <p:cNvPr id="12" name="TextBox 11"/>
+          <p:cNvSpPr txBox="1"/>
+          <p:nvPr/>
+        </p:nvSpPr>
+        <p:spPr>
+          <a:xfrm>
+            <a:off x="868680" y="3858768"/>
+            <a:ext cx="4617720" cy="347472"/>
+          </a:xfrm>
+          <a:prstGeom prst="rect">
+            <a:avLst/>
+          </a:prstGeom>
+          <a:noFill/>
+        </p:spPr>
+        <p:txBody>
+          <a:bodyPr wrap="square" lIns="0" rIns="0" tIns="0" bIns="0">
+            <a:spAutoFit/>
+          </a:bodyPr>
+          <a:lstStyle/>
+          <a:p>
+            <a:pPr>
+              <a:spcAft>
+                <a:spcPts val="200"/>
+              </a:spcAft>
+            </a:pPr>
+            <a:r>
+              <a:rPr sz="1500" b="1">
+                <a:solidFill>
+                  <a:srgbClr val="1E2761"/>
+                </a:solidFill>
+                <a:latin typeface="Calibri"/>
+              </a:rPr>
+              <a:t>METHOD</a:t>
+            </a:r>
+          </a:p>
+        </p:txBody>
+      </p:sp>
+      <p:sp>
+        <p:nvSpPr>
+          <p:cNvPr id="13" name="TextBox 12"/>
+          <p:cNvSpPr txBox="1"/>
+          <p:nvPr/>
+        </p:nvSpPr>
+        <p:spPr>
+          <a:xfrm>
+            <a:off x="868680" y="4297680"/>
+            <a:ext cx="4617720" cy="594360"/>
+          </a:xfrm>
+          <a:prstGeom prst="rect">
+            <a:avLst/>
+          </a:prstGeom>
+          <a:noFill/>
+        </p:spPr>
+        <p:txBody>
+          <a:bodyPr wrap="square" lIns="0" rIns="0" tIns="0" bIns="0">
+            <a:spAutoFit/>
+          </a:bodyPr>
+          <a:lstStyle/>
+          <a:p>
+            <a:pPr>
+              <a:spcAft>
+                <a:spcPts val="200"/>
+              </a:spcAft>
+            </a:pPr>
+            <a:r>
+              <a:rPr sz="1300" b="0">
+                <a:solidFill>
+                  <a:srgbClr val="5B5F6E"/>
+                </a:solidFill>
+                <a:latin typeface="Calibri"/>
+              </a:rPr>
+              <a:t>PyTorch Q-network on a 10-week discounted return (γ = 0.9).</a:t>
+            </a:r>
+          </a:p>
+          <a:p>
+            <a:pPr>
+              <a:spcAft>
+                <a:spcPts val="200"/>
+              </a:spcAft>
+            </a:pPr>
+            <a:r>
+              <a:rPr sz="1300" b="0">
+                <a:solidFill>
+                  <a:srgbClr val="5B5F6E"/>
+                </a:solidFill>
+                <a:latin typeface="Calibri"/>
+              </a:rPr>
+              <a:t>State is the seller's own loyal count, last arm, last profit, week.</a:t>
+            </a:r>
+          </a:p>
+        </p:txBody>
+      </p:sp>
+      <p:sp>
+        <p:nvSpPr>
+          <p:cNvPr id="14" name="Rectangle 13"/>
+          <p:cNvSpPr/>
+          <p:nvPr/>
+        </p:nvSpPr>
+        <p:spPr>
+          <a:xfrm>
+            <a:off x="457200" y="5029200"/>
+            <a:ext cx="292608" cy="292608"/>
+          </a:xfrm>
+          <a:prstGeom prst="rect">
+            <a:avLst/>
+          </a:prstGeom>
+          <a:solidFill>
+            <a:srgbClr val="1E2761"/>
+          </a:solidFill>
+          <a:ln>
+            <a:noFill/>
+          </a:ln>
+        </p:spPr>
+        <p:style>
+          <a:lnRef idx="1">
+            <a:schemeClr val="accent1"/>
+          </a:lnRef>
+          <a:fillRef idx="3">
+            <a:schemeClr val="accent1"/>
+          </a:fillRef>
+          <a:effectRef idx="2">
+            <a:schemeClr val="accent1"/>
+          </a:effectRef>
+          <a:fontRef idx="minor">
+            <a:schemeClr val="lt1"/>
+          </a:fontRef>
+        </p:style>
+        <p:txBody>
+          <a:bodyPr rtlCol="0" anchor="ctr"/>
+          <a:lstStyle/>
+          <a:p/>
+        </p:txBody>
+      </p:sp>
+      <p:sp>
+        <p:nvSpPr>
+          <p:cNvPr id="15" name="TextBox 14"/>
+          <p:cNvSpPr txBox="1"/>
+          <p:nvPr/>
+        </p:nvSpPr>
+        <p:spPr>
+          <a:xfrm>
+            <a:off x="868680" y="5001768"/>
+            <a:ext cx="4617720" cy="347472"/>
+          </a:xfrm>
+          <a:prstGeom prst="rect">
+            <a:avLst/>
+          </a:prstGeom>
+          <a:noFill/>
+        </p:spPr>
+        <p:txBody>
+          <a:bodyPr wrap="square" lIns="0" rIns="0" tIns="0" bIns="0">
+            <a:spAutoFit/>
+          </a:bodyPr>
+          <a:lstStyle/>
+          <a:p>
+            <a:pPr>
+              <a:spcAft>
+                <a:spcPts val="200"/>
+              </a:spcAft>
+            </a:pPr>
+            <a:r>
+              <a:rPr sz="1500" b="1">
+                <a:solidFill>
+                  <a:srgbClr val="1E2761"/>
+                </a:solidFill>
+                <a:latin typeface="Calibri"/>
+              </a:rPr>
+              <a:t>LITERATURE BASIS</a:t>
+            </a:r>
+          </a:p>
+        </p:txBody>
+      </p:sp>
+      <p:sp>
+        <p:nvSpPr>
+          <p:cNvPr id="16" name="TextBox 15"/>
+          <p:cNvSpPr txBox="1"/>
+          <p:nvPr/>
+        </p:nvSpPr>
+        <p:spPr>
+          <a:xfrm>
+            <a:off x="868680" y="5440680"/>
+            <a:ext cx="4617720" cy="1005840"/>
+          </a:xfrm>
+          <a:prstGeom prst="rect">
+            <a:avLst/>
+          </a:prstGeom>
+          <a:noFill/>
+        </p:spPr>
+        <p:txBody>
+          <a:bodyPr wrap="square" lIns="0" rIns="0" tIns="0" bIns="0">
+            <a:spAutoFit/>
+          </a:bodyPr>
+          <a:lstStyle/>
+          <a:p>
+            <a:pPr>
+              <a:spcAft>
+                <a:spcPts val="600"/>
+              </a:spcAft>
+            </a:pPr>
+            <a:r>
+              <a:rPr sz="1100" b="1">
+                <a:solidFill>
+                  <a:srgbClr val="1E2761"/>
+                </a:solidFill>
+                <a:latin typeface="Calibri"/>
+              </a:rPr>
+              <a:t>den Boer &amp; Zwart (2015), </a:t>
+            </a:r>
+            <a:r>
+              <a:rPr sz="1100" b="0">
+                <a:solidFill>
+                  <a:srgbClr val="5B5F6E"/>
+                </a:solidFill>
+                <a:latin typeface="Calibri"/>
+              </a:rPr>
+              <a:t>“Dynamic Pricing and Learning with Finite Inventories” (Op. Res.) — learning to price under a finite-inventory constraint.</a:t>
+            </a:r>
+          </a:p>
+        </p:txBody>
+      </p:sp>
+      <p:sp>
+        <p:nvSpPr>
+          <p:cNvPr id="17" name="Rectangle 16"/>
+          <p:cNvSpPr/>
+          <p:nvPr/>
+        </p:nvSpPr>
+        <p:spPr>
+          <a:xfrm>
+            <a:off x="5943600" y="1417320"/>
+            <a:ext cx="292608" cy="292608"/>
+          </a:xfrm>
+          <a:prstGeom prst="rect">
+            <a:avLst/>
+          </a:prstGeom>
+          <a:solidFill>
+            <a:srgbClr val="1E2761"/>
+          </a:solidFill>
+          <a:ln>
+            <a:noFill/>
+          </a:ln>
+        </p:spPr>
+        <p:style>
+          <a:lnRef idx="1">
+            <a:schemeClr val="accent1"/>
+          </a:lnRef>
+          <a:fillRef idx="3">
+            <a:schemeClr val="accent1"/>
+          </a:fillRef>
+          <a:effectRef idx="2">
+            <a:schemeClr val="accent1"/>
+          </a:effectRef>
+          <a:fontRef idx="minor">
+            <a:schemeClr val="lt1"/>
+          </a:fontRef>
+        </p:style>
+        <p:txBody>
+          <a:bodyPr rtlCol="0" anchor="ctr"/>
+          <a:lstStyle/>
+          <a:p/>
+        </p:txBody>
+      </p:sp>
+      <p:sp>
+        <p:nvSpPr>
+          <p:cNvPr id="18" name="TextBox 17"/>
+          <p:cNvSpPr txBox="1"/>
+          <p:nvPr/>
+        </p:nvSpPr>
+        <p:spPr>
+          <a:xfrm>
+            <a:off x="6355080" y="1389888"/>
+            <a:ext cx="5349240" cy="347472"/>
+          </a:xfrm>
+          <a:prstGeom prst="rect">
+            <a:avLst/>
+          </a:prstGeom>
+          <a:noFill/>
+        </p:spPr>
+        <p:txBody>
+          <a:bodyPr wrap="square" lIns="0" rIns="0" tIns="0" bIns="0">
+            <a:spAutoFit/>
+          </a:bodyPr>
+          <a:lstStyle/>
+          <a:p>
+            <a:pPr>
+              <a:spcAft>
+                <a:spcPts val="200"/>
+              </a:spcAft>
+            </a:pPr>
+            <a:r>
+              <a:rPr sz="1500" b="1">
+                <a:solidFill>
+                  <a:srgbClr val="1E2761"/>
+                </a:solidFill>
+                <a:latin typeface="Calibri"/>
+              </a:rPr>
+              <a:t>KEY RESULTS</a:t>
+            </a:r>
+          </a:p>
+        </p:txBody>
+      </p:sp>
+      <p:graphicFrame>
+        <p:nvGraphicFramePr>
+          <p:cNvPr id="19" name="Table 18"/>
+          <p:cNvGraphicFramePr>
+            <a:graphicFrameLocks noGrp="1"/>
+          </p:cNvGraphicFramePr>
+          <p:nvPr/>
+        </p:nvGraphicFramePr>
+        <p:xfrm>
+          <a:off x="5943600" y="1874519"/>
+          <a:ext cx="5760720" cy="1920240"/>
+        </p:xfrm>
+        <a:graphic>
+          <a:graphicData uri="http://schemas.openxmlformats.org/drawingml/2006/table">
+            <a:tbl>
+              <a:tblPr firstRow="1" bandRow="1">
+                <a:tableStyleId>{5C22544A-7EE6-4342-B048-85BDC9FD1C3A}</a:tableStyleId>
+              </a:tblPr>
+              <a:tblGrid>
+                <a:gridCol w="3200400"/>
+                <a:gridCol w="1463040"/>
+                <a:gridCol w="1097280"/>
+              </a:tblGrid>
+              <a:tr h="274320">
+                <a:tc>
+                  <a:txBody>
+                    <a:bodyPr/>
+                    <a:lstStyle/>
+                    <a:p>
+                      <a:r>
+                        <a:rPr sz="1100" b="1">
+                          <a:solidFill>
+                            <a:srgbClr val="FFFFFF"/>
+                          </a:solidFill>
+                          <a:latin typeface="Calibri"/>
+                        </a:rPr>
+                        <a:t>Metric</a:t>
+                      </a:r>
+                    </a:p>
+                  </a:txBody>
+                  <a:tcPr>
+                    <a:solidFill>
+                      <a:srgbClr val="1E2761"/>
+                    </a:solidFill>
+                  </a:tcPr>
+                </a:tc>
+                <a:tc>
+                  <a:txBody>
+                    <a:bodyPr/>
+                    <a:lstStyle/>
+                    <a:p>
+                      <a:r>
+                        <a:rPr sz="1100" b="1">
+                          <a:solidFill>
+                            <a:srgbClr val="FFFFFF"/>
+                          </a:solidFill>
+                          <a:latin typeface="Calibri"/>
+                        </a:rPr>
+                        <a:t>Value</a:t>
+                      </a:r>
+                    </a:p>
+                  </a:txBody>
+                  <a:tcPr>
+                    <a:solidFill>
+                      <a:srgbClr val="1E2761"/>
+                    </a:solidFill>
+                  </a:tcPr>
+                </a:tc>
+                <a:tc>
+                  <a:txBody>
+                    <a:bodyPr/>
+                    <a:lstStyle/>
+                    <a:p>
+                      <a:r>
+                        <a:rPr sz="1100" b="1">
+                          <a:solidFill>
+                            <a:srgbClr val="FFFFFF"/>
+                          </a:solidFill>
+                          <a:latin typeface="Calibri"/>
+                        </a:rPr>
+                        <a:t/>
+                      </a:r>
+                    </a:p>
+                  </a:txBody>
+                  <a:tcPr>
+                    <a:solidFill>
+                      <a:srgbClr val="1E2761"/>
+                    </a:solidFill>
+                  </a:tcPr>
+                </a:tc>
+              </a:tr>
+              <a:tr h="274320">
+                <a:tc>
+                  <a:txBody>
+                    <a:bodyPr/>
+                    <a:lstStyle/>
+                    <a:p>
+                      <a:r>
+                        <a:rPr sz="1100">
+                          <a:solidFill>
+                            <a:srgbClr val="1E2761"/>
+                          </a:solidFill>
+                          <a:latin typeface="Calibri"/>
+                        </a:rPr>
+                        <a:t>7a heuristic</a:t>
+                      </a:r>
+                    </a:p>
+                  </a:txBody>
+                  <a:tcPr>
+                    <a:solidFill>
+                      <a:srgbClr val="FFFFFF"/>
+                    </a:solidFill>
+                  </a:tcPr>
+                </a:tc>
+                <a:tc>
+                  <a:txBody>
+                    <a:bodyPr/>
+                    <a:lstStyle/>
+                    <a:p>
+                      <a:r>
+                        <a:rPr sz="1100">
+                          <a:solidFill>
+                            <a:srgbClr val="5B5F6E"/>
+                          </a:solidFill>
+                          <a:latin typeface="Calibri"/>
+                        </a:rPr>
+                        <a:t>60.9/wk</a:t>
+                      </a:r>
+                    </a:p>
+                  </a:txBody>
+                  <a:tcPr>
+                    <a:solidFill>
+                      <a:srgbClr val="FFFFFF"/>
+                    </a:solidFill>
+                  </a:tcPr>
+                </a:tc>
+                <a:tc>
+                  <a:txBody>
+                    <a:bodyPr/>
+                    <a:lstStyle/>
+                    <a:p>
+                      <a:pPr algn="ctr"/>
+                      <a:r>
+                        <a:rPr sz="1100" b="1">
+                          <a:solidFill>
+                            <a:srgbClr val="5B5F6E"/>
+                          </a:solidFill>
+                          <a:latin typeface="Calibri"/>
+                        </a:rPr>
+                        <a:t>—</a:t>
+                      </a:r>
+                    </a:p>
+                  </a:txBody>
+                  <a:tcPr>
+                    <a:solidFill>
+                      <a:srgbClr val="FFFFFF"/>
+                    </a:solidFill>
+                  </a:tcPr>
+                </a:tc>
+              </a:tr>
+              <a:tr h="274320">
+                <a:tc>
+                  <a:txBody>
+                    <a:bodyPr/>
+                    <a:lstStyle/>
+                    <a:p>
+                      <a:r>
+                        <a:rPr sz="1100">
+                          <a:solidFill>
+                            <a:srgbClr val="1E2761"/>
+                          </a:solidFill>
+                          <a:latin typeface="Calibri"/>
+                        </a:rPr>
+                        <a:t>7b UCB1 bandit</a:t>
+                      </a:r>
+                    </a:p>
+                  </a:txBody>
+                  <a:tcPr>
+                    <a:solidFill>
+                      <a:srgbClr val="F7F8FC"/>
+                    </a:solidFill>
+                  </a:tcPr>
+                </a:tc>
+                <a:tc>
+                  <a:txBody>
+                    <a:bodyPr/>
+                    <a:lstStyle/>
+                    <a:p>
+                      <a:r>
+                        <a:rPr sz="1100">
+                          <a:solidFill>
+                            <a:srgbClr val="5B5F6E"/>
+                          </a:solidFill>
+                          <a:latin typeface="Calibri"/>
+                        </a:rPr>
+                        <a:t>66.0/wk</a:t>
+                      </a:r>
+                    </a:p>
+                  </a:txBody>
+                  <a:tcPr>
+                    <a:solidFill>
+                      <a:srgbClr val="F7F8FC"/>
+                    </a:solidFill>
+                  </a:tcPr>
+                </a:tc>
+                <a:tc>
+                  <a:txBody>
+                    <a:bodyPr/>
+                    <a:lstStyle/>
+                    <a:p>
+                      <a:pPr algn="ctr"/>
+                      <a:r>
+                        <a:rPr sz="1100" b="1">
+                          <a:solidFill>
+                            <a:srgbClr val="5B5F6E"/>
+                          </a:solidFill>
+                          <a:latin typeface="Calibri"/>
+                        </a:rPr>
+                        <a:t>—</a:t>
+                      </a:r>
+                    </a:p>
+                  </a:txBody>
+                  <a:tcPr>
+                    <a:solidFill>
+                      <a:srgbClr val="F7F8FC"/>
+                    </a:solidFill>
+                  </a:tcPr>
+                </a:tc>
+              </a:tr>
+              <a:tr h="274320">
+                <a:tc>
+                  <a:txBody>
+                    <a:bodyPr/>
+                    <a:lstStyle/>
+                    <a:p>
+                      <a:r>
+                        <a:rPr sz="1100">
+                          <a:solidFill>
+                            <a:srgbClr val="1E2761"/>
+                          </a:solidFill>
+                          <a:latin typeface="Calibri"/>
+                        </a:rPr>
+                        <a:t>7d RL, held-out seeds</a:t>
+                      </a:r>
+                    </a:p>
+                  </a:txBody>
+                  <a:tcPr>
+                    <a:solidFill>
+                      <a:srgbClr val="FFFFFF"/>
+                    </a:solidFill>
+                  </a:tcPr>
+                </a:tc>
+                <a:tc>
+                  <a:txBody>
+                    <a:bodyPr/>
+                    <a:lstStyle/>
+                    <a:p>
+                      <a:r>
+                        <a:rPr sz="1100">
+                          <a:solidFill>
+                            <a:srgbClr val="5B5F6E"/>
+                          </a:solidFill>
+                          <a:latin typeface="Calibri"/>
+                        </a:rPr>
+                        <a:t>65.2/wk</a:t>
+                      </a:r>
+                    </a:p>
+                  </a:txBody>
+                  <a:tcPr>
+                    <a:solidFill>
+                      <a:srgbClr val="FFFFFF"/>
+                    </a:solidFill>
+                  </a:tcPr>
+                </a:tc>
+                <a:tc>
+                  <a:txBody>
+                    <a:bodyPr/>
+                    <a:lstStyle/>
+                    <a:p>
+                      <a:pPr algn="ctr"/>
+                      <a:r>
+                        <a:rPr sz="1100" b="1">
+                          <a:solidFill>
+                            <a:srgbClr val="5B5F6E"/>
+                          </a:solidFill>
+                          <a:latin typeface="Calibri"/>
+                        </a:rPr>
+                        <a:t>—</a:t>
+                      </a:r>
+                    </a:p>
+                  </a:txBody>
+                  <a:tcPr>
+                    <a:solidFill>
+                      <a:srgbClr val="FFFFFF"/>
+                    </a:solidFill>
+                  </a:tcPr>
+                </a:tc>
+              </a:tr>
+              <a:tr h="274320">
+                <a:tc>
+                  <a:txBody>
+                    <a:bodyPr/>
+                    <a:lstStyle/>
+                    <a:p>
+                      <a:r>
+                        <a:rPr sz="1100">
+                          <a:solidFill>
+                            <a:srgbClr val="1E2761"/>
+                          </a:solidFill>
+                          <a:latin typeface="Calibri"/>
+                        </a:rPr>
+                        <a:t>RL vs bandit</a:t>
+                      </a:r>
+                    </a:p>
+                  </a:txBody>
+                  <a:tcPr>
+                    <a:solidFill>
+                      <a:srgbClr val="F7F8FC"/>
+                    </a:solidFill>
+                  </a:tcPr>
+                </a:tc>
+                <a:tc>
+                  <a:txBody>
+                    <a:bodyPr/>
+                    <a:lstStyle/>
+                    <a:p>
+                      <a:r>
+                        <a:rPr sz="1100">
+                          <a:solidFill>
+                            <a:srgbClr val="5B5F6E"/>
+                          </a:solidFill>
+                          <a:latin typeface="Calibri"/>
+                        </a:rPr>
+                        <a:t>-1.3%</a:t>
+                      </a:r>
+                    </a:p>
+                  </a:txBody>
+                  <a:tcPr>
+                    <a:solidFill>
+                      <a:srgbClr val="F7F8FC"/>
+                    </a:solidFill>
+                  </a:tcPr>
+                </a:tc>
+                <a:tc>
+                  <a:txBody>
+                    <a:bodyPr/>
+                    <a:lstStyle/>
+                    <a:p>
+                      <a:pPr algn="ctr"/>
+                      <a:r>
+                        <a:rPr sz="1100" b="1">
+                          <a:solidFill>
+                            <a:srgbClr val="1E7A4D"/>
+                          </a:solidFill>
+                          <a:latin typeface="Calibri"/>
+                        </a:rPr>
+                        <a:t>PASS</a:t>
+                      </a:r>
+                    </a:p>
+                  </a:txBody>
+                  <a:tcPr>
+                    <a:solidFill>
+                      <a:srgbClr val="F7F8FC"/>
+                    </a:solidFill>
+                  </a:tcPr>
+                </a:tc>
+              </a:tr>
+              <a:tr h="274320">
+                <a:tc>
+                  <a:txBody>
+                    <a:bodyPr/>
+                    <a:lstStyle/>
+                    <a:p>
+                      <a:r>
+                        <a:rPr sz="1100">
+                          <a:solidFill>
+                            <a:srgbClr val="1E2761"/>
+                          </a:solidFill>
+                          <a:latin typeface="Calibri"/>
+                        </a:rPr>
+                        <a:t>  its 95% CI vs ±5%</a:t>
+                      </a:r>
+                    </a:p>
+                  </a:txBody>
+                  <a:tcPr>
+                    <a:solidFill>
+                      <a:srgbClr val="FFFFFF"/>
+                    </a:solidFill>
+                  </a:tcPr>
+                </a:tc>
+                <a:tc>
+                  <a:txBody>
+                    <a:bodyPr/>
+                    <a:lstStyle/>
+                    <a:p>
+                      <a:r>
+                        <a:rPr sz="1100">
+                          <a:solidFill>
+                            <a:srgbClr val="5B5F6E"/>
+                          </a:solidFill>
+                          <a:latin typeface="Calibri"/>
+                        </a:rPr>
+                        <a:t>[-2.8%, +0.1%]</a:t>
+                      </a:r>
+                    </a:p>
+                  </a:txBody>
+                  <a:tcPr>
+                    <a:solidFill>
+                      <a:srgbClr val="FFFFFF"/>
+                    </a:solidFill>
+                  </a:tcPr>
+                </a:tc>
+                <a:tc>
+                  <a:txBody>
+                    <a:bodyPr/>
+                    <a:lstStyle/>
+                    <a:p>
+                      <a:pPr algn="ctr"/>
+                      <a:r>
+                        <a:rPr sz="1100" b="1">
+                          <a:solidFill>
+                            <a:srgbClr val="1E7A4D"/>
+                          </a:solidFill>
+                          <a:latin typeface="Calibri"/>
+                        </a:rPr>
+                        <a:t>PASS</a:t>
+                      </a:r>
+                    </a:p>
+                  </a:txBody>
+                  <a:tcPr>
+                    <a:solidFill>
+                      <a:srgbClr val="FFFFFF"/>
+                    </a:solidFill>
+                  </a:tcPr>
+                </a:tc>
+              </a:tr>
+              <a:tr h="274320">
+                <a:tc>
+                  <a:txBody>
+                    <a:bodyPr/>
+                    <a:lstStyle/>
+                    <a:p>
+                      <a:r>
+                        <a:rPr sz="1100">
+                          <a:solidFill>
+                            <a:srgbClr val="1E2761"/>
+                          </a:solidFill>
+                          <a:latin typeface="Calibri"/>
+                        </a:rPr>
+                        <a:t>Week–price correlation</a:t>
+                      </a:r>
+                    </a:p>
+                  </a:txBody>
+                  <a:tcPr>
+                    <a:solidFill>
+                      <a:srgbClr val="F7F8FC"/>
+                    </a:solidFill>
+                  </a:tcPr>
+                </a:tc>
+                <a:tc>
+                  <a:txBody>
+                    <a:bodyPr/>
+                    <a:lstStyle/>
+                    <a:p>
+                      <a:r>
+                        <a:rPr sz="1100">
+                          <a:solidFill>
+                            <a:srgbClr val="5B5F6E"/>
+                          </a:solidFill>
+                          <a:latin typeface="Calibri"/>
+                        </a:rPr>
+                        <a:t>RL 0.30 vs bandit 0.42</a:t>
+                      </a:r>
+                    </a:p>
+                  </a:txBody>
+                  <a:tcPr>
+                    <a:solidFill>
+                      <a:srgbClr val="F7F8FC"/>
+                    </a:solidFill>
+                  </a:tcPr>
+                </a:tc>
+                <a:tc>
+                  <a:txBody>
+                    <a:bodyPr/>
+                    <a:lstStyle/>
+                    <a:p>
+                      <a:pPr algn="ctr"/>
+                      <a:r>
+                        <a:rPr sz="1100" b="1">
+                          <a:solidFill>
+                            <a:srgbClr val="5B5F6E"/>
+                          </a:solidFill>
+                          <a:latin typeface="Calibri"/>
+                        </a:rPr>
+                        <a:t>—</a:t>
+                      </a:r>
+                    </a:p>
+                  </a:txBody>
+                  <a:tcPr>
+                    <a:solidFill>
+                      <a:srgbClr val="F7F8FC"/>
+                    </a:solidFill>
+                  </a:tcPr>
+                </a:tc>
+              </a:tr>
+            </a:tbl>
+          </a:graphicData>
+        </a:graphic>
+      </p:graphicFrame>
+      <p:sp>
+        <p:nvSpPr>
+          <p:cNvPr id="20" name="Rectangle 19"/>
+          <p:cNvSpPr/>
+          <p:nvPr/>
+        </p:nvSpPr>
+        <p:spPr>
+          <a:xfrm>
+            <a:off x="5943600" y="4023360"/>
+            <a:ext cx="292608" cy="292608"/>
+          </a:xfrm>
+          <a:prstGeom prst="rect">
+            <a:avLst/>
+          </a:prstGeom>
+          <a:solidFill>
+            <a:srgbClr val="1E2761"/>
+          </a:solidFill>
+          <a:ln>
+            <a:noFill/>
+          </a:ln>
+        </p:spPr>
+        <p:style>
+          <a:lnRef idx="1">
+            <a:schemeClr val="accent1"/>
+          </a:lnRef>
+          <a:fillRef idx="3">
+            <a:schemeClr val="accent1"/>
+          </a:fillRef>
+          <a:effectRef idx="2">
+            <a:schemeClr val="accent1"/>
+          </a:effectRef>
+          <a:fontRef idx="minor">
+            <a:schemeClr val="lt1"/>
+          </a:fontRef>
+        </p:style>
+        <p:txBody>
+          <a:bodyPr rtlCol="0" anchor="ctr"/>
+          <a:lstStyle/>
+          <a:p/>
+        </p:txBody>
+      </p:sp>
+      <p:sp>
+        <p:nvSpPr>
+          <p:cNvPr id="21" name="TextBox 20"/>
+          <p:cNvSpPr txBox="1"/>
+          <p:nvPr/>
+        </p:nvSpPr>
+        <p:spPr>
+          <a:xfrm>
+            <a:off x="6355080" y="3995928"/>
+            <a:ext cx="5349240" cy="347472"/>
+          </a:xfrm>
+          <a:prstGeom prst="rect">
+            <a:avLst/>
+          </a:prstGeom>
+          <a:noFill/>
+        </p:spPr>
+        <p:txBody>
+          <a:bodyPr wrap="square" lIns="0" rIns="0" tIns="0" bIns="0">
+            <a:spAutoFit/>
+          </a:bodyPr>
+          <a:lstStyle/>
+          <a:p>
+            <a:pPr>
+              <a:spcAft>
+                <a:spcPts val="200"/>
+              </a:spcAft>
+            </a:pPr>
+            <a:r>
+              <a:rPr sz="1500" b="1">
+                <a:solidFill>
+                  <a:srgbClr val="1E2761"/>
+                </a:solidFill>
+                <a:latin typeface="Calibri"/>
+              </a:rPr>
+              <a:t>RESEARCH QUESTION</a:t>
+            </a:r>
+          </a:p>
+        </p:txBody>
+      </p:sp>
+      <p:sp>
+        <p:nvSpPr>
+          <p:cNvPr id="22" name="Rectangle 21"/>
+          <p:cNvSpPr/>
+          <p:nvPr/>
+        </p:nvSpPr>
+        <p:spPr>
+          <a:xfrm>
+            <a:off x="5943600" y="4434840"/>
+            <a:ext cx="5760720" cy="1965960"/>
+          </a:xfrm>
+          <a:prstGeom prst="rect">
+            <a:avLst/>
+          </a:prstGeom>
+          <a:solidFill>
+            <a:srgbClr val="F7F8FC"/>
+          </a:solidFill>
+          <a:ln>
+            <a:noFill/>
+          </a:ln>
+        </p:spPr>
+        <p:style>
+          <a:lnRef idx="1">
+            <a:schemeClr val="accent1"/>
+          </a:lnRef>
+          <a:fillRef idx="3">
+            <a:schemeClr val="accent1"/>
+          </a:fillRef>
+          <a:effectRef idx="2">
+            <a:schemeClr val="accent1"/>
+          </a:effectRef>
+          <a:fontRef idx="minor">
+            <a:schemeClr val="lt1"/>
+          </a:fontRef>
+        </p:style>
+        <p:txBody>
+          <a:bodyPr rtlCol="0" anchor="ctr"/>
+          <a:lstStyle/>
+          <a:p/>
+        </p:txBody>
+      </p:sp>
+      <p:sp>
+        <p:nvSpPr>
+          <p:cNvPr id="23" name="TextBox 22"/>
+          <p:cNvSpPr txBox="1"/>
+          <p:nvPr/>
+        </p:nvSpPr>
+        <p:spPr>
+          <a:xfrm>
+            <a:off x="6217920" y="4572000"/>
+            <a:ext cx="5212080" cy="1737360"/>
+          </a:xfrm>
+          <a:prstGeom prst="rect">
+            <a:avLst/>
+          </a:prstGeom>
+          <a:noFill/>
+        </p:spPr>
+        <p:txBody>
+          <a:bodyPr wrap="square" lIns="0" rIns="0" tIns="0" bIns="0">
+            <a:spAutoFit/>
+          </a:bodyPr>
+          <a:lstStyle/>
+          <a:p>
+            <a:pPr>
+              <a:spcAft>
+                <a:spcPts val="500"/>
+              </a:spcAft>
+            </a:pPr>
+            <a:r>
+              <a:rPr sz="1000" b="0">
+                <a:solidFill>
+                  <a:srgbClr val="5B5F6E"/>
+                </a:solidFill>
+                <a:latin typeface="Calibri"/>
+              </a:rPr>
+              <a:t>Does optimizing cumulative multi-week reward change pricing behaviour or outcomes relative to per-week optimization?</a:t>
+            </a:r>
+          </a:p>
+          <a:p>
+            <a:pPr>
+              <a:spcAft>
+                <a:spcPts val="500"/>
+              </a:spcAft>
+            </a:pPr>
+            <a:r>
+              <a:rPr sz="1000" b="1">
+                <a:solidFill>
+                  <a:srgbClr val="1E2761"/>
+                </a:solidFill>
+                <a:latin typeface="Calibri"/>
+              </a:rPr>
+              <a:t>Finding: </a:t>
+            </a:r>
+            <a:r>
+              <a:rPr sz="1000" b="0">
+                <a:solidFill>
+                  <a:srgbClr val="5B5F6E"/>
+                </a:solidFill>
+                <a:latin typeface="Calibri"/>
+              </a:rPr>
+              <a:t>No — equivalent at -1.3%, CI [-2.8%, +0.1%]. A ten-week horizon converges to what the myopic bandit already found, and the sacrifice-then-recover trajectory is absent (2.24 early vs 2.28 late).</a:t>
+            </a:r>
+          </a:p>
+          <a:p>
+            <a:pPr>
+              <a:spcAft>
+                <a:spcPts val="500"/>
+              </a:spcAft>
+            </a:pPr>
+            <a:r>
+              <a:rPr sz="1000" b="1">
+                <a:solidFill>
+                  <a:srgbClr val="1E2761"/>
+                </a:solidFill>
+                <a:latin typeface="Calibri"/>
+              </a:rPr>
+              <a:t>Caveat: </a:t>
+            </a:r>
+            <a:r>
+              <a:rPr sz="1000" b="0">
+                <a:solidFill>
+                  <a:srgbClr val="5B5F6E"/>
+                </a:solidFill>
+                <a:latin typeface="Calibri"/>
+              </a:rPr>
+              <a:t>The pre-registered signature does not measure what it was meant to: any learner climbing toward a better arm produces a rising price path, and the *myopic* bandit scores higher on it (0.42) than the RL agent (0.30). The null itself traces to loyalty_streak_cap = 3 — a bounded counter that resets on one switch is not a stock, so there is nothing to invest in. Phase 7e tests that directly.</a:t>
             </a:r>
           </a:p>
         </p:txBody>

</xml_diff>

<commit_message>
Phase 8 results with the turnover measurement the tightened claims rest on
Same eight cells, same verdicts; the run now records what separates a flat
seller count from a static market, which is what the corrected wording needed.

Over the final season entry and exit both run and run at nearly the same rate.
Under the capital rule 0.10-0.15 entries a week and 84-88% of firms survive the
season; under the three-week rule 0.37-0.47 and only 48-62%. So roughly half
the market is replaced inside one season while the count does not move - a
stochastic stationary structure, and the reason "equilibrium" was the wrong
word. The three-week rule turns over 3.7x as many firms per week.

The Phase 8 slide is regenerated rather than appended, so the deck carries one
Phase 8 slide with the tightened language rather than two with contradictory
claims.
</commit_message>
<xml_diff>
--- a/project_tracking.pptx
+++ b/project_tracking.pptx
@@ -18,7 +18,7 @@
     <p:sldId id="266" r:id="rId17"/>
     <p:sldId id="267" r:id="rId18"/>
     <p:sldId id="268" r:id="rId19"/>
-    <p:sldId id="269" r:id="rId20"/>
+    <p:sldId id="269" r:id="rId21"/>
   </p:sldIdLst>
   <p:sldSz cx="12191969" cy="6858000" type="screen4x3"/>
   <p:notesSz cx="6858000" cy="9144000"/>
@@ -11011,7 +11011,7 @@
                 </a:solidFill>
                 <a:latin typeface="Calibri"/>
               </a:rPr>
-              <a:t>EMERGENT</a:t>
+              <a:t>DIFFERENTIAL SURVIVAL</a:t>
             </a:r>
           </a:p>
         </p:txBody>
@@ -11783,7 +11783,7 @@
                           </a:solidFill>
                           <a:latin typeface="Calibri"/>
                         </a:rPr>
-                        <a:t>Premium tier, week 0</a:t>
+                        <a:t>Premium tier, week 0 -&gt; 110</a:t>
                       </a:r>
                     </a:p>
                   </a:txBody>
@@ -11805,7 +11805,7 @@
                           </a:solidFill>
                           <a:latin typeface="Calibri"/>
                         </a:rPr>
-                        <a:t>40% of stalls</a:t>
+                        <a:t>40% -&gt; 0%</a:t>
                       </a:r>
                     </a:p>
                   </a:txBody>
@@ -11852,7 +11852,7 @@
                           </a:solidFill>
                           <a:latin typeface="Calibri"/>
                         </a:rPr>
-                        <a:t>Premium tier, week 110</a:t>
+                        <a:t>Stationary count, F=6 / F=12</a:t>
                       </a:r>
                     </a:p>
                   </a:txBody>
@@ -11874,7 +11874,7 @@
                           </a:solidFill>
                           <a:latin typeface="Calibri"/>
                         </a:rPr>
-                        <a:t>0%</a:t>
+                        <a:t>24.9 / 12.4</a:t>
                       </a:r>
                     </a:p>
                   </a:txBody>
@@ -11893,11 +11893,11 @@
                       <a:r>
                         <a:rPr sz="1100" b="1">
                           <a:solidFill>
-                            <a:srgbClr val="5B5F6E"/>
-                          </a:solidFill>
-                          <a:latin typeface="Calibri"/>
-                        </a:rPr>
-                        <a:t>—</a:t>
+                            <a:srgbClr val="1E7A4D"/>
+                          </a:solidFill>
+                          <a:latin typeface="Calibri"/>
+                        </a:rPr>
+                        <a:t>PASS</a:t>
                       </a:r>
                     </a:p>
                   </a:txBody>
@@ -11921,7 +11921,7 @@
                           </a:solidFill>
                           <a:latin typeface="Calibri"/>
                         </a:rPr>
-                        <a:t>Sellers at F=6 / F=12</a:t>
+                        <a:t>Final-season entry / exit</a:t>
                       </a:r>
                     </a:p>
                   </a:txBody>
@@ -11943,7 +11943,7 @@
                           </a:solidFill>
                           <a:latin typeface="Calibri"/>
                         </a:rPr>
-                        <a:t>24.9 / 12.4</a:t>
+                        <a:t>0.10-0.47 per wk</a:t>
                       </a:r>
                     </a:p>
                   </a:txBody>
@@ -11962,11 +11962,11 @@
                       <a:r>
                         <a:rPr sz="1100" b="1">
                           <a:solidFill>
-                            <a:srgbClr val="1E7A4D"/>
-                          </a:solidFill>
-                          <a:latin typeface="Calibri"/>
-                        </a:rPr>
-                        <a:t>PASS</a:t>
+                            <a:srgbClr val="5B5F6E"/>
+                          </a:solidFill>
+                          <a:latin typeface="Calibri"/>
+                        </a:rPr>
+                        <a:t>—</a:t>
                       </a:r>
                     </a:p>
                   </a:txBody>
@@ -11990,7 +11990,7 @@
                           </a:solidFill>
                           <a:latin typeface="Calibri"/>
                         </a:rPr>
-                        <a:t>Churn, streak vs capital</a:t>
+                        <a:t>  firms surviving a season</a:t>
                       </a:r>
                     </a:p>
                   </a:txBody>
@@ -12012,7 +12012,7 @@
                           </a:solidFill>
                           <a:latin typeface="Calibri"/>
                         </a:rPr>
-                        <a:t>2.4x</a:t>
+                        <a:t>48%-88%</a:t>
                       </a:r>
                     </a:p>
                   </a:txBody>
@@ -12059,7 +12059,7 @@
                           </a:solidFill>
                           <a:latin typeface="Calibri"/>
                         </a:rPr>
-                        <a:t>Volatility vs RI DEM</a:t>
+                        <a:t>Turnover, streak vs capital</a:t>
                       </a:r>
                     </a:p>
                   </a:txBody>
@@ -12081,7 +12081,7 @@
                           </a:solidFill>
                           <a:latin typeface="Calibri"/>
                         </a:rPr>
-                        <a:t>12.7% vs 15.2%</a:t>
+                        <a:t>3.7x</a:t>
                       </a:r>
                     </a:p>
                   </a:txBody>
@@ -12368,7 +12368,7 @@
                 </a:solidFill>
                 <a:latin typeface="Calibri"/>
               </a:rPr>
-              <a:t>Yes. The premium tier is competed out of existence in all eight cells, from 40% of stalls to essentially zero, and no rule anywhere reads a class label — verified by swapping the tier names and getting a bit-identical run. Free entry sets the size and the fixed cost sets the equilibrium: 24.9 sellers at a cost of 6, 12.4 at 12. The exit rule changes the churn and not the destination — the three-week rule turns over 2.4x as many firms and lands within 15% of the same count.</a:t>
+              <a:t>Entry/exit dynamics selectively eliminate the premium tier — 40% of stalls to essentially zero in all eight cells — under this population and cost structure. Free entry endogenizes market size and the fixed cost strongly determines its stationary level: 24.9 sellers at a cost of 6, 12.4 at 12. What settles is a *stochastic stationary* structure, not an equilibrium: in the final season entry and exit both run, and under the three-week rule only 48%-62% of firms survive a season while the count does not move.</a:t>
             </a:r>
           </a:p>
           <a:p>
@@ -12393,7 +12393,1576 @@
                 </a:solidFill>
                 <a:latin typeface="Calibri"/>
               </a:rPr>
-              <a:t>Emergent is meant narrowly. The mechanism did not encode the outcome, but *why* the premium tier loses was fixed at Phase 2: 70% of buyers hold a budget of 3.0 against its price of 6.0, so it sells to 30% of the market while paying the same rent. The market discovered what the population already made true. Both halves of the registered mechanism were also inoperative and were replaced at the gate — exit fired on week-0 arithmetic in 100% of seeds, and the unmet-demand entry trigger was identically zero across 1,980 seller-weeks.</a:t>
+              <a:t>Emergent with respect to the decision *rules*, conditional on exogenously specified buyer affordability and seller economics. Swapping the tier names gives a bit-identical run, which proves the outcome is label-invariant — no rule reads a class — but not that the composition is independent of the parameterization: Phase 2 gave 70% of buyers a budget of 3.0 against a premium price of 6.0, and both tiers pay the same rent. The exit rule mainly changes turnover and convergence speed, and the long-run count only modestly (~15%). Season-over-season change 12.7% against the RI DEM reference's 15.2% supports a comparable order of magnitude only — provenance, seller definition and entry/exit definition are unverified, so it is not a reproduction claim.</a:t>
+            </a:r>
+          </a:p>
+        </p:txBody>
+      </p:sp>
+      <p:sp>
+        <p:nvSpPr>
+          <p:cNvPr id="24" name="TextBox 23"/>
+          <p:cNvSpPr txBox="1"/>
+          <p:nvPr/>
+        </p:nvSpPr>
+        <p:spPr>
+          <a:xfrm>
+            <a:off x="457200" y="6446520"/>
+            <a:ext cx="11247120" cy="274320"/>
+          </a:xfrm>
+          <a:prstGeom prst="rect">
+            <a:avLst/>
+          </a:prstGeom>
+          <a:noFill/>
+        </p:spPr>
+        <p:txBody>
+          <a:bodyPr wrap="square" lIns="0" rIns="0" tIns="0" bIns="0">
+            <a:spAutoFit/>
+          </a:bodyPr>
+          <a:lstStyle/>
+          <a:p>
+            <a:pPr>
+              <a:spcAft>
+                <a:spcPts val="200"/>
+              </a:spcAft>
+            </a:pPr>
+            <a:r>
+              <a:rPr sz="950" b="0">
+                <a:solidFill>
+                  <a:srgbClr val="5B5F6E"/>
+                </a:solidFill>
+                <a:latin typeface="Calibri"/>
+              </a:rPr>
+              <a:t>Generated automatically at phase completion  ·  Phase Completion Deliverable  ·  market-sim project</a:t>
+            </a:r>
+          </a:p>
+        </p:txBody>
+      </p:sp>
+    </p:spTree>
+  </p:cSld>
+  <p:clrMapOvr>
+    <a:masterClrMapping/>
+  </p:clrMapOvr>
+</p:sld>
+</file>
+
+<file path=ppt/slides/slide14.xml><?xml version="1.0" encoding="utf-8"?>
+<p:sld xmlns:a="http://schemas.openxmlformats.org/drawingml/2006/main" xmlns:p="http://schemas.openxmlformats.org/presentationml/2006/main" xmlns:r="http://schemas.openxmlformats.org/officeDocument/2006/relationships">
+  <p:cSld>
+    <p:spTree>
+      <p:nvGrpSpPr>
+        <p:cNvPr id="1" name=""/>
+        <p:cNvGrpSpPr/>
+        <p:nvPr/>
+      </p:nvGrpSpPr>
+      <p:grpSpPr/>
+      <p:sp>
+        <p:nvSpPr>
+          <p:cNvPr id="2" name="TextBox 1"/>
+          <p:cNvSpPr txBox="1"/>
+          <p:nvPr/>
+        </p:nvSpPr>
+        <p:spPr>
+          <a:xfrm>
+            <a:off x="457200" y="320040"/>
+            <a:ext cx="8229600" cy="548640"/>
+          </a:xfrm>
+          <a:prstGeom prst="rect">
+            <a:avLst/>
+          </a:prstGeom>
+          <a:noFill/>
+        </p:spPr>
+        <p:txBody>
+          <a:bodyPr wrap="square" lIns="0" rIns="0" tIns="0" bIns="0">
+            <a:spAutoFit/>
+          </a:bodyPr>
+          <a:lstStyle/>
+          <a:p>
+            <a:pPr>
+              <a:spcAft>
+                <a:spcPts val="200"/>
+              </a:spcAft>
+            </a:pPr>
+            <a:r>
+              <a:rPr sz="3200" b="1">
+                <a:solidFill>
+                  <a:srgbClr val="1E2761"/>
+                </a:solidFill>
+                <a:latin typeface="Cambria"/>
+              </a:rPr>
+              <a:t>Phase 8 — Endogenous Market Structure</a:t>
+            </a:r>
+          </a:p>
+        </p:txBody>
+      </p:sp>
+      <p:sp>
+        <p:nvSpPr>
+          <p:cNvPr id="3" name="TextBox 2"/>
+          <p:cNvSpPr txBox="1"/>
+          <p:nvPr/>
+        </p:nvSpPr>
+        <p:spPr>
+          <a:xfrm>
+            <a:off x="457200" y="868680"/>
+            <a:ext cx="8229600" cy="274320"/>
+          </a:xfrm>
+          <a:prstGeom prst="rect">
+            <a:avLst/>
+          </a:prstGeom>
+          <a:noFill/>
+        </p:spPr>
+        <p:txBody>
+          <a:bodyPr wrap="square" lIns="0" rIns="0" tIns="0" bIns="0">
+            <a:spAutoFit/>
+          </a:bodyPr>
+          <a:lstStyle/>
+          <a:p>
+            <a:pPr>
+              <a:spcAft>
+                <a:spcPts val="200"/>
+              </a:spcAft>
+            </a:pPr>
+            <a:r>
+              <a:rPr sz="1200" b="0">
+                <a:solidFill>
+                  <a:srgbClr val="5B5F6E"/>
+                </a:solidFill>
+                <a:latin typeface="Calibri"/>
+              </a:rPr>
+              <a:t>Entry and exit switched on, nothing else changed  ·  git tag: phase8-validated  ·  300 seeds x 110 weeks</a:t>
+            </a:r>
+          </a:p>
+        </p:txBody>
+      </p:sp>
+      <p:sp>
+        <p:nvSpPr>
+          <p:cNvPr id="4" name="Rounded Rectangle 3"/>
+          <p:cNvSpPr/>
+          <p:nvPr/>
+        </p:nvSpPr>
+        <p:spPr>
+          <a:xfrm>
+            <a:off x="9464040" y="365760"/>
+            <a:ext cx="2240280" cy="384048"/>
+          </a:xfrm>
+          <a:prstGeom prst="roundRect">
+            <a:avLst/>
+          </a:prstGeom>
+          <a:solidFill>
+            <a:srgbClr val="1E7A4D"/>
+          </a:solidFill>
+          <a:ln>
+            <a:noFill/>
+          </a:ln>
+        </p:spPr>
+        <p:style>
+          <a:lnRef idx="1">
+            <a:schemeClr val="accent1"/>
+          </a:lnRef>
+          <a:fillRef idx="3">
+            <a:schemeClr val="accent1"/>
+          </a:fillRef>
+          <a:effectRef idx="2">
+            <a:schemeClr val="accent1"/>
+          </a:effectRef>
+          <a:fontRef idx="minor">
+            <a:schemeClr val="lt1"/>
+          </a:fontRef>
+        </p:style>
+        <p:txBody>
+          <a:bodyPr rtlCol="0" anchor="ctr"/>
+          <a:lstStyle/>
+          <a:p>
+            <a:pPr algn="ctr"/>
+            <a:r>
+              <a:rPr sz="1050" b="1">
+                <a:solidFill>
+                  <a:srgbClr val="FFFFFF"/>
+                </a:solidFill>
+                <a:latin typeface="Calibri"/>
+              </a:rPr>
+              <a:t>DIFFERENTIAL SURVIVAL</a:t>
+            </a:r>
+          </a:p>
+        </p:txBody>
+      </p:sp>
+      <p:sp>
+        <p:nvSpPr>
+          <p:cNvPr id="5" name="Rectangle 4"/>
+          <p:cNvSpPr/>
+          <p:nvPr/>
+        </p:nvSpPr>
+        <p:spPr>
+          <a:xfrm>
+            <a:off x="457200" y="1417320"/>
+            <a:ext cx="292608" cy="292608"/>
+          </a:xfrm>
+          <a:prstGeom prst="rect">
+            <a:avLst/>
+          </a:prstGeom>
+          <a:solidFill>
+            <a:srgbClr val="1E2761"/>
+          </a:solidFill>
+          <a:ln>
+            <a:noFill/>
+          </a:ln>
+        </p:spPr>
+        <p:style>
+          <a:lnRef idx="1">
+            <a:schemeClr val="accent1"/>
+          </a:lnRef>
+          <a:fillRef idx="3">
+            <a:schemeClr val="accent1"/>
+          </a:fillRef>
+          <a:effectRef idx="2">
+            <a:schemeClr val="accent1"/>
+          </a:effectRef>
+          <a:fontRef idx="minor">
+            <a:schemeClr val="lt1"/>
+          </a:fontRef>
+        </p:style>
+        <p:txBody>
+          <a:bodyPr rtlCol="0" anchor="ctr"/>
+          <a:lstStyle/>
+          <a:p/>
+        </p:txBody>
+      </p:sp>
+      <p:sp>
+        <p:nvSpPr>
+          <p:cNvPr id="6" name="TextBox 5"/>
+          <p:cNvSpPr txBox="1"/>
+          <p:nvPr/>
+        </p:nvSpPr>
+        <p:spPr>
+          <a:xfrm>
+            <a:off x="868680" y="1389888"/>
+            <a:ext cx="4617720" cy="347472"/>
+          </a:xfrm>
+          <a:prstGeom prst="rect">
+            <a:avLst/>
+          </a:prstGeom>
+          <a:noFill/>
+        </p:spPr>
+        <p:txBody>
+          <a:bodyPr wrap="square" lIns="0" rIns="0" tIns="0" bIns="0">
+            <a:spAutoFit/>
+          </a:bodyPr>
+          <a:lstStyle/>
+          <a:p>
+            <a:pPr>
+              <a:spcAft>
+                <a:spcPts val="200"/>
+              </a:spcAft>
+            </a:pPr>
+            <a:r>
+              <a:rPr sz="1500" b="1">
+                <a:solidFill>
+                  <a:srgbClr val="1E2761"/>
+                </a:solidFill>
+                <a:latin typeface="Calibri"/>
+              </a:rPr>
+              <a:t>AGENTS</a:t>
+            </a:r>
+          </a:p>
+        </p:txBody>
+      </p:sp>
+      <p:sp>
+        <p:nvSpPr>
+          <p:cNvPr id="7" name="TextBox 6"/>
+          <p:cNvSpPr txBox="1"/>
+          <p:nvPr/>
+        </p:nvSpPr>
+        <p:spPr>
+          <a:xfrm>
+            <a:off x="868680" y="1828800"/>
+            <a:ext cx="4617720" cy="566928"/>
+          </a:xfrm>
+          <a:prstGeom prst="rect">
+            <a:avLst/>
+          </a:prstGeom>
+          <a:noFill/>
+        </p:spPr>
+        <p:txBody>
+          <a:bodyPr wrap="square" lIns="0" rIns="0" tIns="0" bIns="0">
+            <a:spAutoFit/>
+          </a:bodyPr>
+          <a:lstStyle/>
+          <a:p>
+            <a:pPr>
+              <a:spcAft>
+                <a:spcPts val="200"/>
+              </a:spcAft>
+            </a:pPr>
+            <a:r>
+              <a:rPr sz="1300" b="1">
+                <a:solidFill>
+                  <a:srgbClr val="1E2761"/>
+                </a:solidFill>
+                <a:latin typeface="Calibri"/>
+              </a:rPr>
+              <a:t>Buyers: </a:t>
+            </a:r>
+            <a:r>
+              <a:rPr sz="1300" b="0">
+                <a:solidFill>
+                  <a:srgbClr val="5B5F6E"/>
+                </a:solidFill>
+                <a:latin typeface="Calibri"/>
+              </a:rPr>
+              <a:t>100 — Poor 70 / Middle 20 / Rich 10, dispersed budgets</a:t>
+            </a:r>
+          </a:p>
+          <a:p>
+            <a:pPr>
+              <a:spcAft>
+                <a:spcPts val="200"/>
+              </a:spcAft>
+            </a:pPr>
+            <a:r>
+              <a:rPr sz="1300" b="1">
+                <a:solidFill>
+                  <a:srgbClr val="1E2761"/>
+                </a:solidFill>
+                <a:latin typeface="Calibri"/>
+              </a:rPr>
+              <a:t>Sellers: </a:t>
+            </a:r>
+            <a:r>
+              <a:rPr sz="1300" b="0">
+                <a:solidFill>
+                  <a:srgbClr val="5B5F6E"/>
+                </a:solidFill>
+                <a:latin typeface="Calibri"/>
+              </a:rPr>
+              <a:t>5 at week 0 — 3 Slow, 2 Shigh — then whoever survives</a:t>
+            </a:r>
+          </a:p>
+        </p:txBody>
+      </p:sp>
+      <p:sp>
+        <p:nvSpPr>
+          <p:cNvPr id="8" name="Rectangle 7"/>
+          <p:cNvSpPr/>
+          <p:nvPr/>
+        </p:nvSpPr>
+        <p:spPr>
+          <a:xfrm>
+            <a:off x="457200" y="2651760"/>
+            <a:ext cx="292608" cy="292608"/>
+          </a:xfrm>
+          <a:prstGeom prst="rect">
+            <a:avLst/>
+          </a:prstGeom>
+          <a:solidFill>
+            <a:srgbClr val="1E2761"/>
+          </a:solidFill>
+          <a:ln>
+            <a:noFill/>
+          </a:ln>
+        </p:spPr>
+        <p:style>
+          <a:lnRef idx="1">
+            <a:schemeClr val="accent1"/>
+          </a:lnRef>
+          <a:fillRef idx="3">
+            <a:schemeClr val="accent1"/>
+          </a:fillRef>
+          <a:effectRef idx="2">
+            <a:schemeClr val="accent1"/>
+          </a:effectRef>
+          <a:fontRef idx="minor">
+            <a:schemeClr val="lt1"/>
+          </a:fontRef>
+        </p:style>
+        <p:txBody>
+          <a:bodyPr rtlCol="0" anchor="ctr"/>
+          <a:lstStyle/>
+          <a:p/>
+        </p:txBody>
+      </p:sp>
+      <p:sp>
+        <p:nvSpPr>
+          <p:cNvPr id="9" name="TextBox 8"/>
+          <p:cNvSpPr txBox="1"/>
+          <p:nvPr/>
+        </p:nvSpPr>
+        <p:spPr>
+          <a:xfrm>
+            <a:off x="868680" y="2624328"/>
+            <a:ext cx="4617720" cy="347472"/>
+          </a:xfrm>
+          <a:prstGeom prst="rect">
+            <a:avLst/>
+          </a:prstGeom>
+          <a:noFill/>
+        </p:spPr>
+        <p:txBody>
+          <a:bodyPr wrap="square" lIns="0" rIns="0" tIns="0" bIns="0">
+            <a:spAutoFit/>
+          </a:bodyPr>
+          <a:lstStyle/>
+          <a:p>
+            <a:pPr>
+              <a:spcAft>
+                <a:spcPts val="200"/>
+              </a:spcAft>
+            </a:pPr>
+            <a:r>
+              <a:rPr sz="1500" b="1">
+                <a:solidFill>
+                  <a:srgbClr val="1E2761"/>
+                </a:solidFill>
+                <a:latin typeface="Calibri"/>
+              </a:rPr>
+              <a:t>ENVIRONMENT &amp; CONTEXT</a:t>
+            </a:r>
+          </a:p>
+        </p:txBody>
+      </p:sp>
+      <p:sp>
+        <p:nvSpPr>
+          <p:cNvPr id="10" name="TextBox 9"/>
+          <p:cNvSpPr txBox="1"/>
+          <p:nvPr/>
+        </p:nvSpPr>
+        <p:spPr>
+          <a:xfrm>
+            <a:off x="868680" y="3063240"/>
+            <a:ext cx="4617720" cy="548640"/>
+          </a:xfrm>
+          <a:prstGeom prst="rect">
+            <a:avLst/>
+          </a:prstGeom>
+          <a:noFill/>
+        </p:spPr>
+        <p:txBody>
+          <a:bodyPr wrap="square" lIns="0" rIns="0" tIns="0" bIns="0">
+            <a:spAutoFit/>
+          </a:bodyPr>
+          <a:lstStyle/>
+          <a:p>
+            <a:pPr>
+              <a:spcAft>
+                <a:spcPts val="200"/>
+              </a:spcAft>
+            </a:pPr>
+            <a:r>
+              <a:rPr sz="1300" b="0">
+                <a:solidFill>
+                  <a:srgbClr val="5B5F6E"/>
+                </a:solidFill>
+                <a:latin typeface="Calibri"/>
+              </a:rPr>
+              <a:t>-  40 fixed slots, drawn at slot width whatever the occupancy, so</a:t>
+            </a:r>
+          </a:p>
+          <a:p>
+            <a:pPr>
+              <a:spcAft>
+                <a:spcPts val="200"/>
+              </a:spcAft>
+            </a:pPr>
+            <a:r>
+              <a:rPr sz="1300" b="0">
+                <a:solidFill>
+                  <a:srgbClr val="5B5F6E"/>
+                </a:solidFill>
+                <a:latin typeface="Calibri"/>
+              </a:rPr>
+              <a:t>   arms with different entry histories stay paired on a seed.</a:t>
+            </a:r>
+          </a:p>
+          <a:p>
+            <a:pPr>
+              <a:spcAft>
+                <a:spcPts val="200"/>
+              </a:spcAft>
+            </a:pPr>
+            <a:r>
+              <a:rPr sz="1300" b="0">
+                <a:solidFill>
+                  <a:srgbClr val="5B5F6E"/>
+                </a:solidFill>
+                <a:latin typeface="Calibri"/>
+              </a:rPr>
+              <a:t>-  price_reference frozen at the week-0 configuration for all 110 weeks.</a:t>
+            </a:r>
+          </a:p>
+        </p:txBody>
+      </p:sp>
+      <p:sp>
+        <p:nvSpPr>
+          <p:cNvPr id="11" name="Rectangle 10"/>
+          <p:cNvSpPr/>
+          <p:nvPr/>
+        </p:nvSpPr>
+        <p:spPr>
+          <a:xfrm>
+            <a:off x="457200" y="3886200"/>
+            <a:ext cx="292608" cy="292608"/>
+          </a:xfrm>
+          <a:prstGeom prst="rect">
+            <a:avLst/>
+          </a:prstGeom>
+          <a:solidFill>
+            <a:srgbClr val="1E2761"/>
+          </a:solidFill>
+          <a:ln>
+            <a:noFill/>
+          </a:ln>
+        </p:spPr>
+        <p:style>
+          <a:lnRef idx="1">
+            <a:schemeClr val="accent1"/>
+          </a:lnRef>
+          <a:fillRef idx="3">
+            <a:schemeClr val="accent1"/>
+          </a:fillRef>
+          <a:effectRef idx="2">
+            <a:schemeClr val="accent1"/>
+          </a:effectRef>
+          <a:fontRef idx="minor">
+            <a:schemeClr val="lt1"/>
+          </a:fontRef>
+        </p:style>
+        <p:txBody>
+          <a:bodyPr rtlCol="0" anchor="ctr"/>
+          <a:lstStyle/>
+          <a:p/>
+        </p:txBody>
+      </p:sp>
+      <p:sp>
+        <p:nvSpPr>
+          <p:cNvPr id="12" name="TextBox 11"/>
+          <p:cNvSpPr txBox="1"/>
+          <p:nvPr/>
+        </p:nvSpPr>
+        <p:spPr>
+          <a:xfrm>
+            <a:off x="868680" y="3858768"/>
+            <a:ext cx="4617720" cy="347472"/>
+          </a:xfrm>
+          <a:prstGeom prst="rect">
+            <a:avLst/>
+          </a:prstGeom>
+          <a:noFill/>
+        </p:spPr>
+        <p:txBody>
+          <a:bodyPr wrap="square" lIns="0" rIns="0" tIns="0" bIns="0">
+            <a:spAutoFit/>
+          </a:bodyPr>
+          <a:lstStyle/>
+          <a:p>
+            <a:pPr>
+              <a:spcAft>
+                <a:spcPts val="200"/>
+              </a:spcAft>
+            </a:pPr>
+            <a:r>
+              <a:rPr sz="1500" b="1">
+                <a:solidFill>
+                  <a:srgbClr val="1E2761"/>
+                </a:solidFill>
+                <a:latin typeface="Calibri"/>
+              </a:rPr>
+              <a:t>METHOD</a:t>
+            </a:r>
+          </a:p>
+        </p:txBody>
+      </p:sp>
+      <p:sp>
+        <p:nvSpPr>
+          <p:cNvPr id="13" name="TextBox 12"/>
+          <p:cNvSpPr txBox="1"/>
+          <p:nvPr/>
+        </p:nvSpPr>
+        <p:spPr>
+          <a:xfrm>
+            <a:off x="868680" y="4297680"/>
+            <a:ext cx="4617720" cy="594360"/>
+          </a:xfrm>
+          <a:prstGeom prst="rect">
+            <a:avLst/>
+          </a:prstGeom>
+          <a:noFill/>
+        </p:spPr>
+        <p:txBody>
+          <a:bodyPr wrap="square" lIns="0" rIns="0" tIns="0" bIns="0">
+            <a:spAutoFit/>
+          </a:bodyPr>
+          <a:lstStyle/>
+          <a:p>
+            <a:pPr>
+              <a:spcAft>
+                <a:spcPts val="200"/>
+              </a:spcAft>
+            </a:pPr>
+            <a:r>
+              <a:rPr sz="1300" b="0">
+                <a:solidFill>
+                  <a:srgbClr val="5B5F6E"/>
+                </a:solidFill>
+                <a:latin typeface="Calibri"/>
+              </a:rPr>
+              <a:t>Entry: copy a stall that is making money, after two weeks of mean</a:t>
+            </a:r>
+          </a:p>
+          <a:p>
+            <a:pPr>
+              <a:spcAft>
+                <a:spcPts val="200"/>
+              </a:spcAft>
+            </a:pPr>
+            <a:r>
+              <a:rPr sz="1300" b="0">
+                <a:solidFill>
+                  <a:srgbClr val="5B5F6E"/>
+                </a:solidFill>
+                <a:latin typeface="Calibri"/>
+              </a:rPr>
+              <a:t>profit above zero. Exit: capital exhausted, or three losing weeks —</a:t>
+            </a:r>
+          </a:p>
+          <a:p>
+            <a:pPr>
+              <a:spcAft>
+                <a:spcPts val="200"/>
+              </a:spcAft>
+            </a:pPr>
+            <a:r>
+              <a:rPr sz="1300" b="0">
+                <a:solidFill>
+                  <a:srgbClr val="5B5F6E"/>
+                </a:solidFill>
+                <a:latin typeface="Calibri"/>
+              </a:rPr>
+              <a:t>both run. Fixed weekly cost swept over 6 / 8 / 10 / 12.</a:t>
+            </a:r>
+          </a:p>
+        </p:txBody>
+      </p:sp>
+      <p:sp>
+        <p:nvSpPr>
+          <p:cNvPr id="14" name="Rectangle 13"/>
+          <p:cNvSpPr/>
+          <p:nvPr/>
+        </p:nvSpPr>
+        <p:spPr>
+          <a:xfrm>
+            <a:off x="457200" y="5029200"/>
+            <a:ext cx="292608" cy="292608"/>
+          </a:xfrm>
+          <a:prstGeom prst="rect">
+            <a:avLst/>
+          </a:prstGeom>
+          <a:solidFill>
+            <a:srgbClr val="1E2761"/>
+          </a:solidFill>
+          <a:ln>
+            <a:noFill/>
+          </a:ln>
+        </p:spPr>
+        <p:style>
+          <a:lnRef idx="1">
+            <a:schemeClr val="accent1"/>
+          </a:lnRef>
+          <a:fillRef idx="3">
+            <a:schemeClr val="accent1"/>
+          </a:fillRef>
+          <a:effectRef idx="2">
+            <a:schemeClr val="accent1"/>
+          </a:effectRef>
+          <a:fontRef idx="minor">
+            <a:schemeClr val="lt1"/>
+          </a:fontRef>
+        </p:style>
+        <p:txBody>
+          <a:bodyPr rtlCol="0" anchor="ctr"/>
+          <a:lstStyle/>
+          <a:p/>
+        </p:txBody>
+      </p:sp>
+      <p:sp>
+        <p:nvSpPr>
+          <p:cNvPr id="15" name="TextBox 14"/>
+          <p:cNvSpPr txBox="1"/>
+          <p:nvPr/>
+        </p:nvSpPr>
+        <p:spPr>
+          <a:xfrm>
+            <a:off x="868680" y="5001768"/>
+            <a:ext cx="4617720" cy="347472"/>
+          </a:xfrm>
+          <a:prstGeom prst="rect">
+            <a:avLst/>
+          </a:prstGeom>
+          <a:noFill/>
+        </p:spPr>
+        <p:txBody>
+          <a:bodyPr wrap="square" lIns="0" rIns="0" tIns="0" bIns="0">
+            <a:spAutoFit/>
+          </a:bodyPr>
+          <a:lstStyle/>
+          <a:p>
+            <a:pPr>
+              <a:spcAft>
+                <a:spcPts val="200"/>
+              </a:spcAft>
+            </a:pPr>
+            <a:r>
+              <a:rPr sz="1500" b="1">
+                <a:solidFill>
+                  <a:srgbClr val="1E2761"/>
+                </a:solidFill>
+                <a:latin typeface="Calibri"/>
+              </a:rPr>
+              <a:t>LITERATURE BASIS</a:t>
+            </a:r>
+          </a:p>
+        </p:txBody>
+      </p:sp>
+      <p:sp>
+        <p:nvSpPr>
+          <p:cNvPr id="16" name="TextBox 15"/>
+          <p:cNvSpPr txBox="1"/>
+          <p:nvPr/>
+        </p:nvSpPr>
+        <p:spPr>
+          <a:xfrm>
+            <a:off x="868680" y="5440680"/>
+            <a:ext cx="4617720" cy="1005840"/>
+          </a:xfrm>
+          <a:prstGeom prst="rect">
+            <a:avLst/>
+          </a:prstGeom>
+          <a:noFill/>
+        </p:spPr>
+        <p:txBody>
+          <a:bodyPr wrap="square" lIns="0" rIns="0" tIns="0" bIns="0">
+            <a:spAutoFit/>
+          </a:bodyPr>
+          <a:lstStyle/>
+          <a:p>
+            <a:pPr>
+              <a:spcAft>
+                <a:spcPts val="600"/>
+              </a:spcAft>
+            </a:pPr>
+            <a:r>
+              <a:rPr sz="1100" b="1">
+                <a:solidFill>
+                  <a:srgbClr val="1E2761"/>
+                </a:solidFill>
+                <a:latin typeface="Calibri"/>
+              </a:rPr>
+              <a:t>Schelling (1971), </a:t>
+            </a:r>
+            <a:r>
+              <a:rPr sz="1100" b="0">
+                <a:solidFill>
+                  <a:srgbClr val="5B5F6E"/>
+                </a:solidFill>
+                <a:latin typeface="Calibri"/>
+              </a:rPr>
+              <a:t>“Dynamic Models of Segregation” (J. Math. Sociology) — origin of the encoded-vs-emergent question this phase tests.</a:t>
+            </a:r>
+          </a:p>
+        </p:txBody>
+      </p:sp>
+      <p:sp>
+        <p:nvSpPr>
+          <p:cNvPr id="17" name="Rectangle 16"/>
+          <p:cNvSpPr/>
+          <p:nvPr/>
+        </p:nvSpPr>
+        <p:spPr>
+          <a:xfrm>
+            <a:off x="5943600" y="1417320"/>
+            <a:ext cx="292608" cy="292608"/>
+          </a:xfrm>
+          <a:prstGeom prst="rect">
+            <a:avLst/>
+          </a:prstGeom>
+          <a:solidFill>
+            <a:srgbClr val="1E2761"/>
+          </a:solidFill>
+          <a:ln>
+            <a:noFill/>
+          </a:ln>
+        </p:spPr>
+        <p:style>
+          <a:lnRef idx="1">
+            <a:schemeClr val="accent1"/>
+          </a:lnRef>
+          <a:fillRef idx="3">
+            <a:schemeClr val="accent1"/>
+          </a:fillRef>
+          <a:effectRef idx="2">
+            <a:schemeClr val="accent1"/>
+          </a:effectRef>
+          <a:fontRef idx="minor">
+            <a:schemeClr val="lt1"/>
+          </a:fontRef>
+        </p:style>
+        <p:txBody>
+          <a:bodyPr rtlCol="0" anchor="ctr"/>
+          <a:lstStyle/>
+          <a:p/>
+        </p:txBody>
+      </p:sp>
+      <p:sp>
+        <p:nvSpPr>
+          <p:cNvPr id="18" name="TextBox 17"/>
+          <p:cNvSpPr txBox="1"/>
+          <p:nvPr/>
+        </p:nvSpPr>
+        <p:spPr>
+          <a:xfrm>
+            <a:off x="6355080" y="1389888"/>
+            <a:ext cx="5349240" cy="347472"/>
+          </a:xfrm>
+          <a:prstGeom prst="rect">
+            <a:avLst/>
+          </a:prstGeom>
+          <a:noFill/>
+        </p:spPr>
+        <p:txBody>
+          <a:bodyPr wrap="square" lIns="0" rIns="0" tIns="0" bIns="0">
+            <a:spAutoFit/>
+          </a:bodyPr>
+          <a:lstStyle/>
+          <a:p>
+            <a:pPr>
+              <a:spcAft>
+                <a:spcPts val="200"/>
+              </a:spcAft>
+            </a:pPr>
+            <a:r>
+              <a:rPr sz="1500" b="1">
+                <a:solidFill>
+                  <a:srgbClr val="1E2761"/>
+                </a:solidFill>
+                <a:latin typeface="Calibri"/>
+              </a:rPr>
+              <a:t>KEY RESULTS</a:t>
+            </a:r>
+          </a:p>
+        </p:txBody>
+      </p:sp>
+      <p:graphicFrame>
+        <p:nvGraphicFramePr>
+          <p:cNvPr id="19" name="Table 18"/>
+          <p:cNvGraphicFramePr>
+            <a:graphicFrameLocks noGrp="1"/>
+          </p:cNvGraphicFramePr>
+          <p:nvPr/>
+        </p:nvGraphicFramePr>
+        <p:xfrm>
+          <a:off x="5943600" y="1874519"/>
+          <a:ext cx="5760720" cy="1920240"/>
+        </p:xfrm>
+        <a:graphic>
+          <a:graphicData uri="http://schemas.openxmlformats.org/drawingml/2006/table">
+            <a:tbl>
+              <a:tblPr firstRow="1" bandRow="1">
+                <a:tableStyleId>{5C22544A-7EE6-4342-B048-85BDC9FD1C3A}</a:tableStyleId>
+              </a:tblPr>
+              <a:tblGrid>
+                <a:gridCol w="3200400"/>
+                <a:gridCol w="1463040"/>
+                <a:gridCol w="1097280"/>
+              </a:tblGrid>
+              <a:tr h="274320">
+                <a:tc>
+                  <a:txBody>
+                    <a:bodyPr/>
+                    <a:lstStyle/>
+                    <a:p>
+                      <a:r>
+                        <a:rPr sz="1100" b="1">
+                          <a:solidFill>
+                            <a:srgbClr val="FFFFFF"/>
+                          </a:solidFill>
+                          <a:latin typeface="Calibri"/>
+                        </a:rPr>
+                        <a:t>Metric</a:t>
+                      </a:r>
+                    </a:p>
+                  </a:txBody>
+                  <a:tcPr>
+                    <a:solidFill>
+                      <a:srgbClr val="1E2761"/>
+                    </a:solidFill>
+                  </a:tcPr>
+                </a:tc>
+                <a:tc>
+                  <a:txBody>
+                    <a:bodyPr/>
+                    <a:lstStyle/>
+                    <a:p>
+                      <a:r>
+                        <a:rPr sz="1100" b="1">
+                          <a:solidFill>
+                            <a:srgbClr val="FFFFFF"/>
+                          </a:solidFill>
+                          <a:latin typeface="Calibri"/>
+                        </a:rPr>
+                        <a:t>Value</a:t>
+                      </a:r>
+                    </a:p>
+                  </a:txBody>
+                  <a:tcPr>
+                    <a:solidFill>
+                      <a:srgbClr val="1E2761"/>
+                    </a:solidFill>
+                  </a:tcPr>
+                </a:tc>
+                <a:tc>
+                  <a:txBody>
+                    <a:bodyPr/>
+                    <a:lstStyle/>
+                    <a:p>
+                      <a:r>
+                        <a:rPr sz="1100" b="1">
+                          <a:solidFill>
+                            <a:srgbClr val="FFFFFF"/>
+                          </a:solidFill>
+                          <a:latin typeface="Calibri"/>
+                        </a:rPr>
+                        <a:t/>
+                      </a:r>
+                    </a:p>
+                  </a:txBody>
+                  <a:tcPr>
+                    <a:solidFill>
+                      <a:srgbClr val="1E2761"/>
+                    </a:solidFill>
+                  </a:tcPr>
+                </a:tc>
+              </a:tr>
+              <a:tr h="274320">
+                <a:tc>
+                  <a:txBody>
+                    <a:bodyPr/>
+                    <a:lstStyle/>
+                    <a:p>
+                      <a:r>
+                        <a:rPr sz="1100">
+                          <a:solidFill>
+                            <a:srgbClr val="1E2761"/>
+                          </a:solidFill>
+                          <a:latin typeface="Calibri"/>
+                        </a:rPr>
+                        <a:t>Premium tier, week 0 -&gt; 110</a:t>
+                      </a:r>
+                    </a:p>
+                  </a:txBody>
+                  <a:tcPr>
+                    <a:solidFill>
+                      <a:srgbClr val="FFFFFF"/>
+                    </a:solidFill>
+                  </a:tcPr>
+                </a:tc>
+                <a:tc>
+                  <a:txBody>
+                    <a:bodyPr/>
+                    <a:lstStyle/>
+                    <a:p>
+                      <a:r>
+                        <a:rPr sz="1100">
+                          <a:solidFill>
+                            <a:srgbClr val="5B5F6E"/>
+                          </a:solidFill>
+                          <a:latin typeface="Calibri"/>
+                        </a:rPr>
+                        <a:t>40% -&gt; 0%</a:t>
+                      </a:r>
+                    </a:p>
+                  </a:txBody>
+                  <a:tcPr>
+                    <a:solidFill>
+                      <a:srgbClr val="FFFFFF"/>
+                    </a:solidFill>
+                  </a:tcPr>
+                </a:tc>
+                <a:tc>
+                  <a:txBody>
+                    <a:bodyPr/>
+                    <a:lstStyle/>
+                    <a:p>
+                      <a:pPr algn="ctr"/>
+                      <a:r>
+                        <a:rPr sz="1100" b="1">
+                          <a:solidFill>
+                            <a:srgbClr val="5B5F6E"/>
+                          </a:solidFill>
+                          <a:latin typeface="Calibri"/>
+                        </a:rPr>
+                        <a:t>—</a:t>
+                      </a:r>
+                    </a:p>
+                  </a:txBody>
+                  <a:tcPr>
+                    <a:solidFill>
+                      <a:srgbClr val="FFFFFF"/>
+                    </a:solidFill>
+                  </a:tcPr>
+                </a:tc>
+              </a:tr>
+              <a:tr h="274320">
+                <a:tc>
+                  <a:txBody>
+                    <a:bodyPr/>
+                    <a:lstStyle/>
+                    <a:p>
+                      <a:r>
+                        <a:rPr sz="1100">
+                          <a:solidFill>
+                            <a:srgbClr val="1E2761"/>
+                          </a:solidFill>
+                          <a:latin typeface="Calibri"/>
+                        </a:rPr>
+                        <a:t>Stationary count, F=6 / F=12</a:t>
+                      </a:r>
+                    </a:p>
+                  </a:txBody>
+                  <a:tcPr>
+                    <a:solidFill>
+                      <a:srgbClr val="F7F8FC"/>
+                    </a:solidFill>
+                  </a:tcPr>
+                </a:tc>
+                <a:tc>
+                  <a:txBody>
+                    <a:bodyPr/>
+                    <a:lstStyle/>
+                    <a:p>
+                      <a:r>
+                        <a:rPr sz="1100">
+                          <a:solidFill>
+                            <a:srgbClr val="5B5F6E"/>
+                          </a:solidFill>
+                          <a:latin typeface="Calibri"/>
+                        </a:rPr>
+                        <a:t>24.9 / 12.4</a:t>
+                      </a:r>
+                    </a:p>
+                  </a:txBody>
+                  <a:tcPr>
+                    <a:solidFill>
+                      <a:srgbClr val="F7F8FC"/>
+                    </a:solidFill>
+                  </a:tcPr>
+                </a:tc>
+                <a:tc>
+                  <a:txBody>
+                    <a:bodyPr/>
+                    <a:lstStyle/>
+                    <a:p>
+                      <a:pPr algn="ctr"/>
+                      <a:r>
+                        <a:rPr sz="1100" b="1">
+                          <a:solidFill>
+                            <a:srgbClr val="1E7A4D"/>
+                          </a:solidFill>
+                          <a:latin typeface="Calibri"/>
+                        </a:rPr>
+                        <a:t>PASS</a:t>
+                      </a:r>
+                    </a:p>
+                  </a:txBody>
+                  <a:tcPr>
+                    <a:solidFill>
+                      <a:srgbClr val="F7F8FC"/>
+                    </a:solidFill>
+                  </a:tcPr>
+                </a:tc>
+              </a:tr>
+              <a:tr h="274320">
+                <a:tc>
+                  <a:txBody>
+                    <a:bodyPr/>
+                    <a:lstStyle/>
+                    <a:p>
+                      <a:r>
+                        <a:rPr sz="1100">
+                          <a:solidFill>
+                            <a:srgbClr val="1E2761"/>
+                          </a:solidFill>
+                          <a:latin typeface="Calibri"/>
+                        </a:rPr>
+                        <a:t>Final-season entry / exit</a:t>
+                      </a:r>
+                    </a:p>
+                  </a:txBody>
+                  <a:tcPr>
+                    <a:solidFill>
+                      <a:srgbClr val="FFFFFF"/>
+                    </a:solidFill>
+                  </a:tcPr>
+                </a:tc>
+                <a:tc>
+                  <a:txBody>
+                    <a:bodyPr/>
+                    <a:lstStyle/>
+                    <a:p>
+                      <a:r>
+                        <a:rPr sz="1100">
+                          <a:solidFill>
+                            <a:srgbClr val="5B5F6E"/>
+                          </a:solidFill>
+                          <a:latin typeface="Calibri"/>
+                        </a:rPr>
+                        <a:t>0.10-0.47 per wk</a:t>
+                      </a:r>
+                    </a:p>
+                  </a:txBody>
+                  <a:tcPr>
+                    <a:solidFill>
+                      <a:srgbClr val="FFFFFF"/>
+                    </a:solidFill>
+                  </a:tcPr>
+                </a:tc>
+                <a:tc>
+                  <a:txBody>
+                    <a:bodyPr/>
+                    <a:lstStyle/>
+                    <a:p>
+                      <a:pPr algn="ctr"/>
+                      <a:r>
+                        <a:rPr sz="1100" b="1">
+                          <a:solidFill>
+                            <a:srgbClr val="5B5F6E"/>
+                          </a:solidFill>
+                          <a:latin typeface="Calibri"/>
+                        </a:rPr>
+                        <a:t>—</a:t>
+                      </a:r>
+                    </a:p>
+                  </a:txBody>
+                  <a:tcPr>
+                    <a:solidFill>
+                      <a:srgbClr val="FFFFFF"/>
+                    </a:solidFill>
+                  </a:tcPr>
+                </a:tc>
+              </a:tr>
+              <a:tr h="274320">
+                <a:tc>
+                  <a:txBody>
+                    <a:bodyPr/>
+                    <a:lstStyle/>
+                    <a:p>
+                      <a:r>
+                        <a:rPr sz="1100">
+                          <a:solidFill>
+                            <a:srgbClr val="1E2761"/>
+                          </a:solidFill>
+                          <a:latin typeface="Calibri"/>
+                        </a:rPr>
+                        <a:t>  firms surviving a season</a:t>
+                      </a:r>
+                    </a:p>
+                  </a:txBody>
+                  <a:tcPr>
+                    <a:solidFill>
+                      <a:srgbClr val="F7F8FC"/>
+                    </a:solidFill>
+                  </a:tcPr>
+                </a:tc>
+                <a:tc>
+                  <a:txBody>
+                    <a:bodyPr/>
+                    <a:lstStyle/>
+                    <a:p>
+                      <a:r>
+                        <a:rPr sz="1100">
+                          <a:solidFill>
+                            <a:srgbClr val="5B5F6E"/>
+                          </a:solidFill>
+                          <a:latin typeface="Calibri"/>
+                        </a:rPr>
+                        <a:t>48%-88%</a:t>
+                      </a:r>
+                    </a:p>
+                  </a:txBody>
+                  <a:tcPr>
+                    <a:solidFill>
+                      <a:srgbClr val="F7F8FC"/>
+                    </a:solidFill>
+                  </a:tcPr>
+                </a:tc>
+                <a:tc>
+                  <a:txBody>
+                    <a:bodyPr/>
+                    <a:lstStyle/>
+                    <a:p>
+                      <a:pPr algn="ctr"/>
+                      <a:r>
+                        <a:rPr sz="1100" b="1">
+                          <a:solidFill>
+                            <a:srgbClr val="5B5F6E"/>
+                          </a:solidFill>
+                          <a:latin typeface="Calibri"/>
+                        </a:rPr>
+                        <a:t>—</a:t>
+                      </a:r>
+                    </a:p>
+                  </a:txBody>
+                  <a:tcPr>
+                    <a:solidFill>
+                      <a:srgbClr val="F7F8FC"/>
+                    </a:solidFill>
+                  </a:tcPr>
+                </a:tc>
+              </a:tr>
+              <a:tr h="274320">
+                <a:tc>
+                  <a:txBody>
+                    <a:bodyPr/>
+                    <a:lstStyle/>
+                    <a:p>
+                      <a:r>
+                        <a:rPr sz="1100">
+                          <a:solidFill>
+                            <a:srgbClr val="1E2761"/>
+                          </a:solidFill>
+                          <a:latin typeface="Calibri"/>
+                        </a:rPr>
+                        <a:t>Turnover, streak vs capital</a:t>
+                      </a:r>
+                    </a:p>
+                  </a:txBody>
+                  <a:tcPr>
+                    <a:solidFill>
+                      <a:srgbClr val="FFFFFF"/>
+                    </a:solidFill>
+                  </a:tcPr>
+                </a:tc>
+                <a:tc>
+                  <a:txBody>
+                    <a:bodyPr/>
+                    <a:lstStyle/>
+                    <a:p>
+                      <a:r>
+                        <a:rPr sz="1100">
+                          <a:solidFill>
+                            <a:srgbClr val="5B5F6E"/>
+                          </a:solidFill>
+                          <a:latin typeface="Calibri"/>
+                        </a:rPr>
+                        <a:t>3.7x</a:t>
+                      </a:r>
+                    </a:p>
+                  </a:txBody>
+                  <a:tcPr>
+                    <a:solidFill>
+                      <a:srgbClr val="FFFFFF"/>
+                    </a:solidFill>
+                  </a:tcPr>
+                </a:tc>
+                <a:tc>
+                  <a:txBody>
+                    <a:bodyPr/>
+                    <a:lstStyle/>
+                    <a:p>
+                      <a:pPr algn="ctr"/>
+                      <a:r>
+                        <a:rPr sz="1100" b="1">
+                          <a:solidFill>
+                            <a:srgbClr val="5B5F6E"/>
+                          </a:solidFill>
+                          <a:latin typeface="Calibri"/>
+                        </a:rPr>
+                        <a:t>—</a:t>
+                      </a:r>
+                    </a:p>
+                  </a:txBody>
+                  <a:tcPr>
+                    <a:solidFill>
+                      <a:srgbClr val="FFFFFF"/>
+                    </a:solidFill>
+                  </a:tcPr>
+                </a:tc>
+              </a:tr>
+              <a:tr h="274320">
+                <a:tc>
+                  <a:txBody>
+                    <a:bodyPr/>
+                    <a:lstStyle/>
+                    <a:p>
+                      <a:r>
+                        <a:rPr sz="1100">
+                          <a:solidFill>
+                            <a:srgbClr val="1E2761"/>
+                          </a:solidFill>
+                          <a:latin typeface="Calibri"/>
+                        </a:rPr>
+                        <a:t>Peak sellers vs capacity</a:t>
+                      </a:r>
+                    </a:p>
+                  </a:txBody>
+                  <a:tcPr>
+                    <a:solidFill>
+                      <a:srgbClr val="F7F8FC"/>
+                    </a:solidFill>
+                  </a:tcPr>
+                </a:tc>
+                <a:tc>
+                  <a:txBody>
+                    <a:bodyPr/>
+                    <a:lstStyle/>
+                    <a:p>
+                      <a:r>
+                        <a:rPr sz="1100">
+                          <a:solidFill>
+                            <a:srgbClr val="5B5F6E"/>
+                          </a:solidFill>
+                          <a:latin typeface="Calibri"/>
+                        </a:rPr>
+                        <a:t>28 of 40</a:t>
+                      </a:r>
+                    </a:p>
+                  </a:txBody>
+                  <a:tcPr>
+                    <a:solidFill>
+                      <a:srgbClr val="F7F8FC"/>
+                    </a:solidFill>
+                  </a:tcPr>
+                </a:tc>
+                <a:tc>
+                  <a:txBody>
+                    <a:bodyPr/>
+                    <a:lstStyle/>
+                    <a:p>
+                      <a:pPr algn="ctr"/>
+                      <a:r>
+                        <a:rPr sz="1100" b="1">
+                          <a:solidFill>
+                            <a:srgbClr val="1E7A4D"/>
+                          </a:solidFill>
+                          <a:latin typeface="Calibri"/>
+                        </a:rPr>
+                        <a:t>PASS</a:t>
+                      </a:r>
+                    </a:p>
+                  </a:txBody>
+                  <a:tcPr>
+                    <a:solidFill>
+                      <a:srgbClr val="F7F8FC"/>
+                    </a:solidFill>
+                  </a:tcPr>
+                </a:tc>
+              </a:tr>
+            </a:tbl>
+          </a:graphicData>
+        </a:graphic>
+      </p:graphicFrame>
+      <p:sp>
+        <p:nvSpPr>
+          <p:cNvPr id="20" name="Rectangle 19"/>
+          <p:cNvSpPr/>
+          <p:nvPr/>
+        </p:nvSpPr>
+        <p:spPr>
+          <a:xfrm>
+            <a:off x="5943600" y="4023360"/>
+            <a:ext cx="292608" cy="292608"/>
+          </a:xfrm>
+          <a:prstGeom prst="rect">
+            <a:avLst/>
+          </a:prstGeom>
+          <a:solidFill>
+            <a:srgbClr val="1E2761"/>
+          </a:solidFill>
+          <a:ln>
+            <a:noFill/>
+          </a:ln>
+        </p:spPr>
+        <p:style>
+          <a:lnRef idx="1">
+            <a:schemeClr val="accent1"/>
+          </a:lnRef>
+          <a:fillRef idx="3">
+            <a:schemeClr val="accent1"/>
+          </a:fillRef>
+          <a:effectRef idx="2">
+            <a:schemeClr val="accent1"/>
+          </a:effectRef>
+          <a:fontRef idx="minor">
+            <a:schemeClr val="lt1"/>
+          </a:fontRef>
+        </p:style>
+        <p:txBody>
+          <a:bodyPr rtlCol="0" anchor="ctr"/>
+          <a:lstStyle/>
+          <a:p/>
+        </p:txBody>
+      </p:sp>
+      <p:sp>
+        <p:nvSpPr>
+          <p:cNvPr id="21" name="TextBox 20"/>
+          <p:cNvSpPr txBox="1"/>
+          <p:nvPr/>
+        </p:nvSpPr>
+        <p:spPr>
+          <a:xfrm>
+            <a:off x="6355080" y="3995928"/>
+            <a:ext cx="5349240" cy="347472"/>
+          </a:xfrm>
+          <a:prstGeom prst="rect">
+            <a:avLst/>
+          </a:prstGeom>
+          <a:noFill/>
+        </p:spPr>
+        <p:txBody>
+          <a:bodyPr wrap="square" lIns="0" rIns="0" tIns="0" bIns="0">
+            <a:spAutoFit/>
+          </a:bodyPr>
+          <a:lstStyle/>
+          <a:p>
+            <a:pPr>
+              <a:spcAft>
+                <a:spcPts val="200"/>
+              </a:spcAft>
+            </a:pPr>
+            <a:r>
+              <a:rPr sz="1500" b="1">
+                <a:solidFill>
+                  <a:srgbClr val="1E2761"/>
+                </a:solidFill>
+                <a:latin typeface="Calibri"/>
+              </a:rPr>
+              <a:t>RESEARCH QUESTION</a:t>
+            </a:r>
+          </a:p>
+        </p:txBody>
+      </p:sp>
+      <p:sp>
+        <p:nvSpPr>
+          <p:cNvPr id="22" name="Rectangle 21"/>
+          <p:cNvSpPr/>
+          <p:nvPr/>
+        </p:nvSpPr>
+        <p:spPr>
+          <a:xfrm>
+            <a:off x="5943600" y="4434840"/>
+            <a:ext cx="5760720" cy="1965960"/>
+          </a:xfrm>
+          <a:prstGeom prst="rect">
+            <a:avLst/>
+          </a:prstGeom>
+          <a:solidFill>
+            <a:srgbClr val="F7F8FC"/>
+          </a:solidFill>
+          <a:ln>
+            <a:noFill/>
+          </a:ln>
+        </p:spPr>
+        <p:style>
+          <a:lnRef idx="1">
+            <a:schemeClr val="accent1"/>
+          </a:lnRef>
+          <a:fillRef idx="3">
+            <a:schemeClr val="accent1"/>
+          </a:fillRef>
+          <a:effectRef idx="2">
+            <a:schemeClr val="accent1"/>
+          </a:effectRef>
+          <a:fontRef idx="minor">
+            <a:schemeClr val="lt1"/>
+          </a:fontRef>
+        </p:style>
+        <p:txBody>
+          <a:bodyPr rtlCol="0" anchor="ctr"/>
+          <a:lstStyle/>
+          <a:p/>
+        </p:txBody>
+      </p:sp>
+      <p:sp>
+        <p:nvSpPr>
+          <p:cNvPr id="23" name="TextBox 22"/>
+          <p:cNvSpPr txBox="1"/>
+          <p:nvPr/>
+        </p:nvSpPr>
+        <p:spPr>
+          <a:xfrm>
+            <a:off x="6217920" y="4572000"/>
+            <a:ext cx="5212080" cy="1737360"/>
+          </a:xfrm>
+          <a:prstGeom prst="rect">
+            <a:avLst/>
+          </a:prstGeom>
+          <a:noFill/>
+        </p:spPr>
+        <p:txBody>
+          <a:bodyPr wrap="square" lIns="0" rIns="0" tIns="0" bIns="0">
+            <a:spAutoFit/>
+          </a:bodyPr>
+          <a:lstStyle/>
+          <a:p>
+            <a:pPr>
+              <a:spcAft>
+                <a:spcPts val="500"/>
+              </a:spcAft>
+            </a:pPr>
+            <a:r>
+              <a:rPr sz="1000" b="0">
+                <a:solidFill>
+                  <a:srgbClr val="5B5F6E"/>
+                </a:solidFill>
+                <a:latin typeface="Calibri"/>
+              </a:rPr>
+              <a:t>Can repeated micro-level interaction produce macro-level market structure without that structure being programmed in?</a:t>
+            </a:r>
+          </a:p>
+          <a:p>
+            <a:pPr>
+              <a:spcAft>
+                <a:spcPts val="500"/>
+              </a:spcAft>
+            </a:pPr>
+            <a:r>
+              <a:rPr sz="1000" b="1">
+                <a:solidFill>
+                  <a:srgbClr val="1E2761"/>
+                </a:solidFill>
+                <a:latin typeface="Calibri"/>
+              </a:rPr>
+              <a:t>Finding: </a:t>
+            </a:r>
+            <a:r>
+              <a:rPr sz="1000" b="0">
+                <a:solidFill>
+                  <a:srgbClr val="5B5F6E"/>
+                </a:solidFill>
+                <a:latin typeface="Calibri"/>
+              </a:rPr>
+              <a:t>Entry/exit dynamics selectively eliminate the premium tier — 40% of stalls to essentially zero in all eight cells — under this population and cost structure. Free entry endogenizes market size and the fixed cost strongly determines its stationary level: 24.9 sellers at a cost of 6, 12.4 at 12. What settles is a *stochastic stationary* structure, not an equilibrium: in the final season entry and exit both run, and under the three-week rule only 48%-62% of firms survive a season while the count does not move.</a:t>
+            </a:r>
+          </a:p>
+          <a:p>
+            <a:pPr>
+              <a:spcAft>
+                <a:spcPts val="500"/>
+              </a:spcAft>
+            </a:pPr>
+            <a:r>
+              <a:rPr sz="1000" b="1">
+                <a:solidFill>
+                  <a:srgbClr val="1E2761"/>
+                </a:solidFill>
+                <a:latin typeface="Calibri"/>
+              </a:rPr>
+              <a:t>Caveat: </a:t>
+            </a:r>
+            <a:r>
+              <a:rPr sz="1000" b="0">
+                <a:solidFill>
+                  <a:srgbClr val="5B5F6E"/>
+                </a:solidFill>
+                <a:latin typeface="Calibri"/>
+              </a:rPr>
+              <a:t>Emergent with respect to the decision *rules*, conditional on exogenously specified buyer affordability and seller economics. Swapping the tier names gives a bit-identical run, which proves the outcome is label-invariant — no rule reads a class — but not that the composition is independent of the parameterization: Phase 2 gave 70% of buyers a budget of 3.0 against a premium price of 6.0, and both tiers pay the same rent. The exit rule mainly changes turnover and convergence speed, and the long-run count only modestly (~15%). Season-over-season change 12.7% against the RI DEM reference's 15.2% supports a comparable order of magnitude only — provenance, seller definition and entry/exit definition are unverified, so it is not a reproduction claim.</a:t>
             </a:r>
           </a:p>
         </p:txBody>

</xml_diff>